<commit_message>
feat: complete CampusMatch demo and HiClaw integration
</commit_message>
<xml_diff>
--- a/show/CampusMatch-初赛方案.pptx
+++ b/show/CampusMatch-初赛方案.pptx
@@ -2,26 +2,26 @@
 <file path=ppt/presentation.xml><?xml version="1.0" encoding="utf-8"?>
 <p:presentation xmlns:p="http://schemas.openxmlformats.org/presentationml/2006/main">
   <p:sldMasterIdLst>
-    <p:sldMasterId xmlns:r="http://schemas.openxmlformats.org/officeDocument/2006/relationships" id="2147483648" r:id="Rb7bca8ff63e74f29"/>
+    <p:sldMasterId xmlns:r="http://schemas.openxmlformats.org/officeDocument/2006/relationships" id="2147483648" r:id="R6f619a042c324bb7"/>
   </p:sldMasterIdLst>
   <p:notesMasterIdLst>
-    <p:notesMasterId xmlns:r="http://schemas.openxmlformats.org/officeDocument/2006/relationships" r:id="R056854d8f0f844e0"/>
+    <p:notesMasterId xmlns:r="http://schemas.openxmlformats.org/officeDocument/2006/relationships" r:id="Refd76d7cb0814d09"/>
   </p:notesMasterIdLst>
   <p:sldIdLst>
-    <p:sldId xmlns:r="http://schemas.openxmlformats.org/officeDocument/2006/relationships" id="256" r:id="R88e2b5d113564696"/>
-    <p:sldId xmlns:r="http://schemas.openxmlformats.org/officeDocument/2006/relationships" id="257" r:id="R11f97bb4b38e4483"/>
-    <p:sldId xmlns:r="http://schemas.openxmlformats.org/officeDocument/2006/relationships" id="258" r:id="R9e72060fe94a4a97"/>
-    <p:sldId xmlns:r="http://schemas.openxmlformats.org/officeDocument/2006/relationships" id="259" r:id="Ra0291c5a87e94031"/>
-    <p:sldId xmlns:r="http://schemas.openxmlformats.org/officeDocument/2006/relationships" id="260" r:id="Re171c4226c36438c"/>
-    <p:sldId xmlns:r="http://schemas.openxmlformats.org/officeDocument/2006/relationships" id="261" r:id="R42e601eba60c442c"/>
-    <p:sldId xmlns:r="http://schemas.openxmlformats.org/officeDocument/2006/relationships" id="262" r:id="Ra764fad8913f4603"/>
-    <p:sldId xmlns:r="http://schemas.openxmlformats.org/officeDocument/2006/relationships" id="263" r:id="R4a6b7fb1b3a44836"/>
-    <p:sldId xmlns:r="http://schemas.openxmlformats.org/officeDocument/2006/relationships" id="264" r:id="Rcc2d31de09e743c4"/>
-    <p:sldId xmlns:r="http://schemas.openxmlformats.org/officeDocument/2006/relationships" id="265" r:id="R18f692ac74914706"/>
-    <p:sldId xmlns:r="http://schemas.openxmlformats.org/officeDocument/2006/relationships" id="266" r:id="R827609401c4048d5"/>
-    <p:sldId xmlns:r="http://schemas.openxmlformats.org/officeDocument/2006/relationships" id="267" r:id="R4ccce09b6ad84ff9"/>
-    <p:sldId xmlns:r="http://schemas.openxmlformats.org/officeDocument/2006/relationships" id="268" r:id="Rebae151f1f5a4ddc"/>
-    <p:sldId xmlns:r="http://schemas.openxmlformats.org/officeDocument/2006/relationships" id="269" r:id="R91f026f77b8e4189"/>
+    <p:sldId xmlns:r="http://schemas.openxmlformats.org/officeDocument/2006/relationships" id="256" r:id="R0f1361ac009845ed"/>
+    <p:sldId xmlns:r="http://schemas.openxmlformats.org/officeDocument/2006/relationships" id="257" r:id="R84aee65d155a4ac2"/>
+    <p:sldId xmlns:r="http://schemas.openxmlformats.org/officeDocument/2006/relationships" id="258" r:id="Rb1d2a9e8f0b84166"/>
+    <p:sldId xmlns:r="http://schemas.openxmlformats.org/officeDocument/2006/relationships" id="259" r:id="R3db627cd2fff4321"/>
+    <p:sldId xmlns:r="http://schemas.openxmlformats.org/officeDocument/2006/relationships" id="260" r:id="R98d1b9f21c2c4ba6"/>
+    <p:sldId xmlns:r="http://schemas.openxmlformats.org/officeDocument/2006/relationships" id="261" r:id="Rc92792d34f5d4301"/>
+    <p:sldId xmlns:r="http://schemas.openxmlformats.org/officeDocument/2006/relationships" id="262" r:id="R6191012e139c4376"/>
+    <p:sldId xmlns:r="http://schemas.openxmlformats.org/officeDocument/2006/relationships" id="263" r:id="Ra6f241e82c414471"/>
+    <p:sldId xmlns:r="http://schemas.openxmlformats.org/officeDocument/2006/relationships" id="264" r:id="R362ea0f5a3754bff"/>
+    <p:sldId xmlns:r="http://schemas.openxmlformats.org/officeDocument/2006/relationships" id="265" r:id="R46e418ee705f4031"/>
+    <p:sldId xmlns:r="http://schemas.openxmlformats.org/officeDocument/2006/relationships" id="266" r:id="R6b82e0c476964bd9"/>
+    <p:sldId xmlns:r="http://schemas.openxmlformats.org/officeDocument/2006/relationships" id="267" r:id="Rfe15b2e2b9e64bd2"/>
+    <p:sldId xmlns:r="http://schemas.openxmlformats.org/officeDocument/2006/relationships" id="268" r:id="R2d3fd792ba6f4e01"/>
+    <p:sldId xmlns:r="http://schemas.openxmlformats.org/officeDocument/2006/relationships" id="269" r:id="R99014c8b3e36452c"/>
   </p:sldIdLst>
   <p:sldSz cx="12192000" cy="6858000"/>
   <p:notesSz cx="6858000" cy="9144000"/>
@@ -740,7 +740,32 @@
           <a:lstStyle xmlns:a="http://schemas.openxmlformats.org/drawingml/2006/main"/>
           <a:p xmlns:a="http://schemas.openxmlformats.org/drawingml/2006/main">
             <a:r>
-              <a:t>Demo 不是只走成功路径。我们用合成简历和岗位先生成画像与匹配，再故意让 Coach 产生一个无证据数字，Audit 必须阻断；修复并确认后才导出。离线模式保证复现，在线模式展示真实协同。</a:t>
+              <a:t>两条演示路径均已验证：浏览器确定性链路便于非技术评委复现；HiClaw Team 链路由 Career Navigator 委派 Profile、Job、Match、Coach、Audit 五阶段执行。Audit 在未人工批准时返回 BLOCK + APPROVAL_REQUIRED，证明人工门没有被绕过。</a:t>
+            </a:r>
+          </a:p>
+          <a:p xmlns:a="http://schemas.openxmlformats.org/drawingml/2006/main">
+            <a:r>
+              <a:t/>
+            </a:r>
+          </a:p>
+          <a:p xmlns:a="http://schemas.openxmlformats.org/drawingml/2006/main">
+            <a:r>
+              <a:t>[Sources]</a:t>
+            </a:r>
+          </a:p>
+          <a:p xmlns:a="http://schemas.openxmlformats.org/drawingml/2006/main">
+            <a:r>
+              <a:t>- Internal verification: demo/README.md</a:t>
+            </a:r>
+          </a:p>
+          <a:p xmlns:a="http://schemas.openxmlformats.org/drawingml/2006/main">
+            <a:r>
+              <a:t>- Internal verification: show/19-Demo实机验收记录.md</a:t>
+            </a:r>
+          </a:p>
+          <a:p xmlns:a="http://schemas.openxmlformats.org/drawingml/2006/main">
+            <a:r>
+              <a:t>[/Sources]</a:t>
             </a:r>
           </a:p>
         </p:txBody>
@@ -810,7 +835,27 @@
           <a:lstStyle xmlns:a="http://schemas.openxmlformats.org/drawingml/2006/main"/>
           <a:p xmlns:a="http://schemas.openxmlformats.org/drawingml/2006/main">
             <a:r>
-              <a:t>本页全部是复赛实现后的验收目标，不是已经取得的成绩。我们会用固定合成数据集跑正常、缺证、工具失败、歧视条件和危机信号用例，并保存 Trace 和审核结果。</a:t>
+              <a:t>本页只列 2026-08-14 本地实测：50 项自动化测试通过；浏览器控制台 0 错误；风险性别条件 0 次进入评分；六个 Worker MCP 全部健康；真实 Team 的五个专业阶段全部完成；最终业务状态 READY。77/85 是合成案例输出，不代表招聘效果。</a:t>
+            </a:r>
+          </a:p>
+          <a:p xmlns:a="http://schemas.openxmlformats.org/drawingml/2006/main">
+            <a:r>
+              <a:t/>
+            </a:r>
+          </a:p>
+          <a:p xmlns:a="http://schemas.openxmlformats.org/drawingml/2006/main">
+            <a:r>
+              <a:t>[Sources]</a:t>
+            </a:r>
+          </a:p>
+          <a:p xmlns:a="http://schemas.openxmlformats.org/drawingml/2006/main">
+            <a:r>
+              <a:t>- Internal verification: show/19-Demo实机验收记录.md</a:t>
+            </a:r>
+          </a:p>
+          <a:p xmlns:a="http://schemas.openxmlformats.org/drawingml/2006/main">
+            <a:r>
+              <a:t>[/Sources]</a:t>
             </a:r>
           </a:p>
         </p:txBody>
@@ -1490,7 +1535,7 @@
           <a:lstStyle xmlns:a="http://schemas.openxmlformats.org/drawingml/2006/main"/>
           <a:p xmlns:a="http://schemas.openxmlformats.org/drawingml/2006/main">
             <a:r>
-              <a:t>Match Agent 不只给一个分数。它把匹配度和证据置信度分开，并逐项标出符合、部分符合、缺少证据、冲突和风险排除。页面数据为合成演示，只展示交互与解释方式。</a:t>
+              <a:t>本页使用当前可执行合成案例：岗位匹配度 77、证据覆盖度 85。逐项状态来自真实 Demo 输出；“女性优先”被标记为 POLICY_EXCLUDED，不参与评分。匹配分不代表录用概率，缺少证据不等于缺少能力。</a:t>
             </a:r>
           </a:p>
           <a:p xmlns:a="http://schemas.openxmlformats.org/drawingml/2006/main">
@@ -1505,7 +1550,7 @@
           </a:p>
           <a:p xmlns:a="http://schemas.openxmlformats.org/drawingml/2006/main">
             <a:r>
-              <a:t>- All numbers on this slide are synthetic demonstration data created for the CampusMatch prototype.</a:t>
+              <a:t>- Internal verification: show/19-Demo实机验收记录.md</a:t>
             </a:r>
           </a:p>
           <a:p xmlns:a="http://schemas.openxmlformats.org/drawingml/2006/main">
@@ -1578,7 +1623,7 @@
   </p:cSld>
   <p:clrMap bg1="lt1" tx1="dk1" bg2="lt2" tx2="dk2" accent1="accent1" accent2="accent2" accent3="accent3" accent4="accent4" accent5="accent5" accent6="accent6" hlink="hlink" folHlink="folHlink"/>
   <p:sldLayoutIdLst>
-    <p:sldLayoutId xmlns:r="http://schemas.openxmlformats.org/officeDocument/2006/relationships" id="2147483649" r:id="R57680f59f21e43bd"/>
+    <p:sldLayoutId xmlns:r="http://schemas.openxmlformats.org/officeDocument/2006/relationships" id="2147483649" r:id="R4023eae5152240d3"/>
   </p:sldLayoutIdLst>
   <p:txStyles>
     <p:titleStyle>
@@ -2279,14 +2324,14 @@
       </p:grpSpPr>
       <p:pic>
         <p:nvPicPr>
-          <p:cNvPr id="11" name=""/>
+          <p:cNvPr id="12" name=""/>
           <p:cNvPicPr>
             <a:picLocks xmlns:a="http://schemas.openxmlformats.org/drawingml/2006/main" noChangeAspect="1"/>
           </p:cNvPicPr>
           <p:nvPr/>
         </p:nvPicPr>
         <p:blipFill>
-          <a:blip xmlns:r="http://schemas.openxmlformats.org/officeDocument/2006/relationships" xmlns:a="http://schemas.openxmlformats.org/drawingml/2006/main" r:embed="Rb5989923df144141"/>
+          <a:blip xmlns:r="http://schemas.openxmlformats.org/officeDocument/2006/relationships" xmlns:a="http://schemas.openxmlformats.org/drawingml/2006/main" r:embed="R5c533de4355d4d88"/>
           <a:srcRect xmlns:a="http://schemas.openxmlformats.org/drawingml/2006/main" l="0" t="112" r="0" b="112"/>
           <a:stretch xmlns:a="http://schemas.openxmlformats.org/drawingml/2006/main">
             <a:fillRect l="0" t="0" r="0" b="0"/>
@@ -2365,6 +2410,7 @@
           <a:lstStyle xmlns:a="http://schemas.openxmlformats.org/drawingml/2006/main"/>
           <a:p xmlns:a="http://schemas.openxmlformats.org/drawingml/2006/main">
             <a:pPr algn="l">
+              <a:buNone/>
               <a:defRPr sz="1050" b="1">
                 <a:solidFill>
                   <a:srgbClr val="1666D3"/>
@@ -2423,6 +2469,7 @@
           <a:lstStyle xmlns:a="http://schemas.openxmlformats.org/drawingml/2006/main"/>
           <a:p xmlns:a="http://schemas.openxmlformats.org/drawingml/2006/main">
             <a:pPr algn="l">
+              <a:buNone/>
               <a:defRPr sz="4050" b="1">
                 <a:solidFill>
                   <a:srgbClr val="101828"/>
@@ -2481,6 +2528,7 @@
           <a:lstStyle xmlns:a="http://schemas.openxmlformats.org/drawingml/2006/main"/>
           <a:p xmlns:a="http://schemas.openxmlformats.org/drawingml/2006/main">
             <a:pPr algn="l">
+              <a:buNone/>
               <a:defRPr sz="2100" b="1">
                 <a:solidFill>
                   <a:srgbClr val="0B3B75"/>
@@ -2539,6 +2587,7 @@
           <a:lstStyle xmlns:a="http://schemas.openxmlformats.org/drawingml/2006/main"/>
           <a:p xmlns:a="http://schemas.openxmlformats.org/drawingml/2006/main">
             <a:pPr algn="l">
+              <a:buNone/>
               <a:defRPr sz="1800" b="0">
                 <a:solidFill>
                   <a:srgbClr val="667085"/>
@@ -2603,6 +2652,7 @@
           <a:lstStyle xmlns:a="http://schemas.openxmlformats.org/drawingml/2006/main"/>
           <a:p xmlns:a="http://schemas.openxmlformats.org/drawingml/2006/main">
             <a:pPr algn="ctr">
+              <a:buNone/>
               <a:defRPr sz="1050" b="1">
                 <a:solidFill>
                   <a:srgbClr val="1666D3"/>
@@ -2667,6 +2717,7 @@
           <a:lstStyle xmlns:a="http://schemas.openxmlformats.org/drawingml/2006/main"/>
           <a:p xmlns:a="http://schemas.openxmlformats.org/drawingml/2006/main">
             <a:pPr algn="ctr">
+              <a:buNone/>
               <a:defRPr sz="1050" b="1">
                 <a:solidFill>
                   <a:srgbClr val="16865B"/>
@@ -2731,6 +2782,7 @@
           <a:lstStyle xmlns:a="http://schemas.openxmlformats.org/drawingml/2006/main"/>
           <a:p xmlns:a="http://schemas.openxmlformats.org/drawingml/2006/main">
             <a:pPr algn="ctr">
+              <a:buNone/>
               <a:defRPr sz="1050" b="1">
                 <a:solidFill>
                   <a:srgbClr val="7047B8"/>
@@ -2789,6 +2841,7 @@
           <a:lstStyle xmlns:a="http://schemas.openxmlformats.org/drawingml/2006/main"/>
           <a:p xmlns:a="http://schemas.openxmlformats.org/drawingml/2006/main">
             <a:pPr algn="l">
+              <a:buNone/>
               <a:defRPr sz="975" b="0">
                 <a:solidFill>
                   <a:srgbClr val="98A2B3"/>
@@ -2876,6 +2929,7 @@
           <a:lstStyle xmlns:a="http://schemas.openxmlformats.org/drawingml/2006/main"/>
           <a:p xmlns:a="http://schemas.openxmlformats.org/drawingml/2006/main">
             <a:pPr algn="l">
+              <a:buNone/>
               <a:defRPr sz="900" b="1">
                 <a:solidFill>
                   <a:srgbClr val="1666D3"/>
@@ -2934,6 +2988,7 @@
           <a:lstStyle xmlns:a="http://schemas.openxmlformats.org/drawingml/2006/main"/>
           <a:p xmlns:a="http://schemas.openxmlformats.org/drawingml/2006/main">
             <a:pPr algn="l">
+              <a:buNone/>
               <a:defRPr sz="2550" b="1">
                 <a:solidFill>
                   <a:srgbClr val="101828"/>
@@ -2959,7 +3014,7 @@
       </p:sp>
       <p:cxnSp>
         <p:nvCxnSpPr>
-          <p:cNvPr id="32" name="header-line-10"/>
+          <p:cNvPr id="38" name="header-line-10"/>
           <p:cNvCxnSpPr/>
           <p:nvPr/>
         </p:nvCxnSpPr>
@@ -3049,6 +3104,7 @@
           <a:lstStyle xmlns:a="http://schemas.openxmlformats.org/drawingml/2006/main"/>
           <a:p xmlns:a="http://schemas.openxmlformats.org/drawingml/2006/main">
             <a:pPr algn="l">
+              <a:buNone/>
               <a:defRPr sz="1050" b="1">
                 <a:solidFill>
                   <a:srgbClr val="1666D3"/>
@@ -3107,6 +3163,7 @@
           <a:lstStyle xmlns:a="http://schemas.openxmlformats.org/drawingml/2006/main"/>
           <a:p xmlns:a="http://schemas.openxmlformats.org/drawingml/2006/main">
             <a:pPr algn="l">
+              <a:buNone/>
               <a:defRPr sz="1725" b="1">
                 <a:solidFill>
                   <a:srgbClr val="0B3B75"/>
@@ -3165,6 +3222,7 @@
           <a:lstStyle xmlns:a="http://schemas.openxmlformats.org/drawingml/2006/main"/>
           <a:p xmlns:a="http://schemas.openxmlformats.org/drawingml/2006/main">
             <a:pPr algn="l">
+              <a:buNone/>
               <a:defRPr sz="1200" b="1">
                 <a:solidFill>
                   <a:srgbClr val="101828"/>
@@ -3188,6 +3246,7 @@
           </a:p>
           <a:p xmlns:a="http://schemas.openxmlformats.org/drawingml/2006/main">
             <a:pPr algn="l">
+              <a:buNone/>
               <a:defRPr sz="1200" b="1">
                 <a:solidFill>
                   <a:srgbClr val="101828"/>
@@ -3211,6 +3270,7 @@
           </a:p>
           <a:p xmlns:a="http://schemas.openxmlformats.org/drawingml/2006/main">
             <a:pPr algn="l">
+              <a:buNone/>
               <a:defRPr sz="1200" b="1">
                 <a:solidFill>
                   <a:srgbClr val="101828"/>
@@ -3234,6 +3294,7 @@
           </a:p>
           <a:p xmlns:a="http://schemas.openxmlformats.org/drawingml/2006/main">
             <a:pPr algn="l">
+              <a:buNone/>
               <a:defRPr sz="1200" b="1">
                 <a:solidFill>
                   <a:srgbClr val="101828"/>
@@ -3292,6 +3353,7 @@
           <a:lstStyle xmlns:a="http://schemas.openxmlformats.org/drawingml/2006/main"/>
           <a:p xmlns:a="http://schemas.openxmlformats.org/drawingml/2006/main">
             <a:pPr algn="ctr">
+              <a:buNone/>
               <a:defRPr sz="1875" b="1">
                 <a:solidFill>
                   <a:srgbClr val="98A2B3"/>
@@ -3385,6 +3447,7 @@
           <a:lstStyle xmlns:a="http://schemas.openxmlformats.org/drawingml/2006/main"/>
           <a:p xmlns:a="http://schemas.openxmlformats.org/drawingml/2006/main">
             <a:pPr algn="l">
+              <a:buNone/>
               <a:defRPr sz="1050" b="1">
                 <a:solidFill>
                   <a:srgbClr val="98A2B3"/>
@@ -3443,6 +3506,7 @@
           <a:lstStyle xmlns:a="http://schemas.openxmlformats.org/drawingml/2006/main"/>
           <a:p xmlns:a="http://schemas.openxmlformats.org/drawingml/2006/main">
             <a:pPr algn="l">
+              <a:buNone/>
               <a:defRPr sz="1725" b="1">
                 <a:solidFill>
                   <a:srgbClr val="101828"/>
@@ -3501,6 +3565,7 @@
           <a:lstStyle xmlns:a="http://schemas.openxmlformats.org/drawingml/2006/main"/>
           <a:p xmlns:a="http://schemas.openxmlformats.org/drawingml/2006/main">
             <a:pPr algn="ctr">
+              <a:buNone/>
               <a:defRPr sz="1275" b="1">
                 <a:solidFill>
                   <a:srgbClr val="667085"/>
@@ -3524,6 +3589,7 @@
           </a:p>
           <a:p xmlns:a="http://schemas.openxmlformats.org/drawingml/2006/main">
             <a:pPr algn="ctr">
+              <a:buNone/>
               <a:defRPr sz="1275" b="1">
                 <a:solidFill>
                   <a:srgbClr val="667085"/>
@@ -3582,6 +3648,7 @@
           <a:lstStyle xmlns:a="http://schemas.openxmlformats.org/drawingml/2006/main"/>
           <a:p xmlns:a="http://schemas.openxmlformats.org/drawingml/2006/main">
             <a:pPr algn="ctr">
+              <a:buNone/>
               <a:defRPr sz="1875" b="1">
                 <a:solidFill>
                   <a:srgbClr val="98A2B3"/>
@@ -3675,6 +3742,7 @@
           <a:lstStyle xmlns:a="http://schemas.openxmlformats.org/drawingml/2006/main"/>
           <a:p xmlns:a="http://schemas.openxmlformats.org/drawingml/2006/main">
             <a:pPr algn="l">
+              <a:buNone/>
               <a:defRPr sz="1050" b="1">
                 <a:solidFill>
                   <a:srgbClr val="C83838"/>
@@ -3733,6 +3801,7 @@
           <a:lstStyle xmlns:a="http://schemas.openxmlformats.org/drawingml/2006/main"/>
           <a:p xmlns:a="http://schemas.openxmlformats.org/drawingml/2006/main">
             <a:pPr algn="l">
+              <a:buNone/>
               <a:defRPr sz="1725" b="1">
                 <a:solidFill>
                   <a:srgbClr val="C83838"/>
@@ -3791,6 +3860,7 @@
           <a:lstStyle xmlns:a="http://schemas.openxmlformats.org/drawingml/2006/main"/>
           <a:p xmlns:a="http://schemas.openxmlformats.org/drawingml/2006/main">
             <a:pPr algn="ctr">
+              <a:buNone/>
               <a:defRPr sz="1200" b="1">
                 <a:solidFill>
                   <a:srgbClr val="101828"/>
@@ -3814,6 +3884,7 @@
           </a:p>
           <a:p xmlns:a="http://schemas.openxmlformats.org/drawingml/2006/main">
             <a:pPr algn="ctr">
+              <a:buNone/>
               <a:defRPr sz="1200" b="1">
                 <a:solidFill>
                   <a:srgbClr val="101828"/>
@@ -3872,6 +3943,7 @@
           <a:lstStyle xmlns:a="http://schemas.openxmlformats.org/drawingml/2006/main"/>
           <a:p xmlns:a="http://schemas.openxmlformats.org/drawingml/2006/main">
             <a:pPr algn="l">
+              <a:buNone/>
               <a:defRPr sz="1050" b="1">
                 <a:solidFill>
                   <a:srgbClr val="98A2B3"/>
@@ -3936,6 +4008,7 @@
           <a:lstStyle xmlns:a="http://schemas.openxmlformats.org/drawingml/2006/main"/>
           <a:p xmlns:a="http://schemas.openxmlformats.org/drawingml/2006/main">
             <a:pPr algn="ctr">
+              <a:buNone/>
               <a:defRPr sz="1425" b="1">
                 <a:solidFill>
                   <a:srgbClr val="C77800"/>
@@ -3959,6 +4032,7 @@
           </a:p>
           <a:p xmlns:a="http://schemas.openxmlformats.org/drawingml/2006/main">
             <a:pPr algn="ctr">
+              <a:buNone/>
               <a:defRPr sz="1425" b="1">
                 <a:solidFill>
                   <a:srgbClr val="C77800"/>
@@ -4017,6 +4091,7 @@
           <a:lstStyle xmlns:a="http://schemas.openxmlformats.org/drawingml/2006/main"/>
           <a:p xmlns:a="http://schemas.openxmlformats.org/drawingml/2006/main">
             <a:pPr algn="ctr">
+              <a:buNone/>
               <a:defRPr sz="1800" b="1">
                 <a:solidFill>
                   <a:srgbClr val="98A2B3"/>
@@ -4081,6 +4156,7 @@
           <a:lstStyle xmlns:a="http://schemas.openxmlformats.org/drawingml/2006/main"/>
           <a:p xmlns:a="http://schemas.openxmlformats.org/drawingml/2006/main">
             <a:pPr algn="ctr">
+              <a:buNone/>
               <a:defRPr sz="1500" b="1">
                 <a:solidFill>
                   <a:srgbClr val="FFFFFF"/>
@@ -4104,6 +4180,7 @@
           </a:p>
           <a:p xmlns:a="http://schemas.openxmlformats.org/drawingml/2006/main">
             <a:pPr algn="ctr">
+              <a:buNone/>
               <a:defRPr sz="1500" b="1">
                 <a:solidFill>
                   <a:srgbClr val="FFFFFF"/>
@@ -4162,6 +4239,7 @@
           <a:lstStyle xmlns:a="http://schemas.openxmlformats.org/drawingml/2006/main"/>
           <a:p xmlns:a="http://schemas.openxmlformats.org/drawingml/2006/main">
             <a:pPr algn="ctr">
+              <a:buNone/>
               <a:defRPr sz="1800" b="1">
                 <a:solidFill>
                   <a:srgbClr val="98A2B3"/>
@@ -4226,6 +4304,7 @@
           <a:lstStyle xmlns:a="http://schemas.openxmlformats.org/drawingml/2006/main"/>
           <a:p xmlns:a="http://schemas.openxmlformats.org/drawingml/2006/main">
             <a:pPr algn="ctr">
+              <a:buNone/>
               <a:defRPr sz="1425" b="1">
                 <a:solidFill>
                   <a:srgbClr val="1666D3"/>
@@ -4249,6 +4328,7 @@
           </a:p>
           <a:p xmlns:a="http://schemas.openxmlformats.org/drawingml/2006/main">
             <a:pPr algn="ctr">
+              <a:buNone/>
               <a:defRPr sz="1425" b="1">
                 <a:solidFill>
                   <a:srgbClr val="1666D3"/>
@@ -4307,6 +4387,7 @@
           <a:lstStyle xmlns:a="http://schemas.openxmlformats.org/drawingml/2006/main"/>
           <a:p xmlns:a="http://schemas.openxmlformats.org/drawingml/2006/main">
             <a:pPr algn="ctr">
+              <a:buNone/>
               <a:defRPr sz="1800" b="1">
                 <a:solidFill>
                   <a:srgbClr val="98A2B3"/>
@@ -4371,6 +4452,7 @@
           <a:lstStyle xmlns:a="http://schemas.openxmlformats.org/drawingml/2006/main"/>
           <a:p xmlns:a="http://schemas.openxmlformats.org/drawingml/2006/main">
             <a:pPr algn="ctr">
+              <a:buNone/>
               <a:defRPr sz="1500" b="1">
                 <a:solidFill>
                   <a:srgbClr val="FFFFFF"/>
@@ -4394,6 +4476,7 @@
           </a:p>
           <a:p xmlns:a="http://schemas.openxmlformats.org/drawingml/2006/main">
             <a:pPr algn="ctr">
+              <a:buNone/>
               <a:defRPr sz="1500" b="1">
                 <a:solidFill>
                   <a:srgbClr val="FFFFFF"/>
@@ -4458,6 +4541,7 @@
           <a:lstStyle xmlns:a="http://schemas.openxmlformats.org/drawingml/2006/main"/>
           <a:p xmlns:a="http://schemas.openxmlformats.org/drawingml/2006/main">
             <a:pPr algn="ctr">
+              <a:buNone/>
               <a:defRPr sz="1050" b="1">
                 <a:solidFill>
                   <a:srgbClr val="101828"/>
@@ -4516,6 +4600,7 @@
           <a:lstStyle xmlns:a="http://schemas.openxmlformats.org/drawingml/2006/main"/>
           <a:p xmlns:a="http://schemas.openxmlformats.org/drawingml/2006/main">
             <a:pPr algn="r">
+              <a:buNone/>
               <a:defRPr sz="750" b="0">
                 <a:solidFill>
                   <a:srgbClr val="98A2B3"/>
@@ -4574,6 +4659,7 @@
           <a:lstStyle xmlns:a="http://schemas.openxmlformats.org/drawingml/2006/main"/>
           <a:p xmlns:a="http://schemas.openxmlformats.org/drawingml/2006/main">
             <a:pPr algn="l">
+              <a:buNone/>
               <a:defRPr sz="750" b="0">
                 <a:solidFill>
                   <a:srgbClr val="98A2B3"/>
@@ -4632,6 +4718,7 @@
           <a:lstStyle xmlns:a="http://schemas.openxmlformats.org/drawingml/2006/main"/>
           <a:p xmlns:a="http://schemas.openxmlformats.org/drawingml/2006/main">
             <a:pPr algn="r">
+              <a:buNone/>
               <a:defRPr sz="825" b="1">
                 <a:solidFill>
                   <a:srgbClr val="98A2B3"/>
@@ -4719,6 +4806,7 @@
           <a:lstStyle xmlns:a="http://schemas.openxmlformats.org/drawingml/2006/main"/>
           <a:p xmlns:a="http://schemas.openxmlformats.org/drawingml/2006/main">
             <a:pPr algn="l">
+              <a:buNone/>
               <a:defRPr sz="900" b="1">
                 <a:solidFill>
                   <a:srgbClr val="1666D3"/>
@@ -4777,6 +4865,7 @@
           <a:lstStyle xmlns:a="http://schemas.openxmlformats.org/drawingml/2006/main"/>
           <a:p xmlns:a="http://schemas.openxmlformats.org/drawingml/2006/main">
             <a:pPr algn="l">
+              <a:buNone/>
               <a:defRPr sz="2550" b="1">
                 <a:solidFill>
                   <a:srgbClr val="101828"/>
@@ -4802,7 +4891,7 @@
       </p:sp>
       <p:cxnSp>
         <p:nvCxnSpPr>
-          <p:cNvPr id="22" name="header-line-11"/>
+          <p:cNvPr id="54" name="header-line-11"/>
           <p:cNvCxnSpPr/>
           <p:nvPr/>
         </p:nvCxnSpPr>
@@ -4898,6 +4987,7 @@
           <a:lstStyle xmlns:a="http://schemas.openxmlformats.org/drawingml/2006/main"/>
           <a:p xmlns:a="http://schemas.openxmlformats.org/drawingml/2006/main">
             <a:pPr algn="ctr">
+              <a:buNone/>
               <a:defRPr sz="1275" b="1">
                 <a:solidFill>
                   <a:srgbClr val="FFFFFF"/>
@@ -4956,6 +5046,7 @@
           <a:lstStyle xmlns:a="http://schemas.openxmlformats.org/drawingml/2006/main"/>
           <a:p xmlns:a="http://schemas.openxmlformats.org/drawingml/2006/main">
             <a:pPr algn="l">
+              <a:buNone/>
               <a:defRPr sz="1350" b="1">
                 <a:solidFill>
                   <a:srgbClr val="101828"/>
@@ -4979,6 +5070,7 @@
           </a:p>
           <a:p xmlns:a="http://schemas.openxmlformats.org/drawingml/2006/main">
             <a:pPr algn="l">
+              <a:buNone/>
               <a:defRPr sz="1350" b="1">
                 <a:solidFill>
                   <a:srgbClr val="101828"/>
@@ -5002,6 +5094,7 @@
           </a:p>
           <a:p xmlns:a="http://schemas.openxmlformats.org/drawingml/2006/main">
             <a:pPr algn="l">
+              <a:buNone/>
               <a:defRPr sz="1350" b="1">
                 <a:solidFill>
                   <a:srgbClr val="101828"/>
@@ -5101,6 +5194,7 @@
           <a:lstStyle xmlns:a="http://schemas.openxmlformats.org/drawingml/2006/main"/>
           <a:p xmlns:a="http://schemas.openxmlformats.org/drawingml/2006/main">
             <a:pPr algn="ctr">
+              <a:buNone/>
               <a:defRPr sz="1275" b="1">
                 <a:solidFill>
                   <a:srgbClr val="FFFFFF"/>
@@ -5159,6 +5253,7 @@
           <a:lstStyle xmlns:a="http://schemas.openxmlformats.org/drawingml/2006/main"/>
           <a:p xmlns:a="http://schemas.openxmlformats.org/drawingml/2006/main">
             <a:pPr algn="l">
+              <a:buNone/>
               <a:defRPr sz="1350" b="1">
                 <a:solidFill>
                   <a:srgbClr val="101828"/>
@@ -5182,6 +5277,7 @@
           </a:p>
           <a:p xmlns:a="http://schemas.openxmlformats.org/drawingml/2006/main">
             <a:pPr algn="l">
+              <a:buNone/>
               <a:defRPr sz="1350" b="1">
                 <a:solidFill>
                   <a:srgbClr val="101828"/>
@@ -5205,6 +5301,7 @@
           </a:p>
           <a:p xmlns:a="http://schemas.openxmlformats.org/drawingml/2006/main">
             <a:pPr algn="l">
+              <a:buNone/>
               <a:defRPr sz="1350" b="1">
                 <a:solidFill>
                   <a:srgbClr val="101828"/>
@@ -5304,6 +5401,7 @@
           <a:lstStyle xmlns:a="http://schemas.openxmlformats.org/drawingml/2006/main"/>
           <a:p xmlns:a="http://schemas.openxmlformats.org/drawingml/2006/main">
             <a:pPr algn="ctr">
+              <a:buNone/>
               <a:defRPr sz="1275" b="1">
                 <a:solidFill>
                   <a:srgbClr val="FFFFFF"/>
@@ -5362,6 +5460,7 @@
           <a:lstStyle xmlns:a="http://schemas.openxmlformats.org/drawingml/2006/main"/>
           <a:p xmlns:a="http://schemas.openxmlformats.org/drawingml/2006/main">
             <a:pPr algn="l">
+              <a:buNone/>
               <a:defRPr sz="1350" b="1">
                 <a:solidFill>
                   <a:srgbClr val="101828"/>
@@ -5385,6 +5484,7 @@
           </a:p>
           <a:p xmlns:a="http://schemas.openxmlformats.org/drawingml/2006/main">
             <a:pPr algn="l">
+              <a:buNone/>
               <a:defRPr sz="1350" b="1">
                 <a:solidFill>
                   <a:srgbClr val="101828"/>
@@ -5408,6 +5508,7 @@
           </a:p>
           <a:p xmlns:a="http://schemas.openxmlformats.org/drawingml/2006/main">
             <a:pPr algn="l">
+              <a:buNone/>
               <a:defRPr sz="1350" b="1">
                 <a:solidFill>
                   <a:srgbClr val="101828"/>
@@ -5507,6 +5608,7 @@
           <a:lstStyle xmlns:a="http://schemas.openxmlformats.org/drawingml/2006/main"/>
           <a:p xmlns:a="http://schemas.openxmlformats.org/drawingml/2006/main">
             <a:pPr algn="ctr">
+              <a:buNone/>
               <a:defRPr sz="1275" b="1">
                 <a:solidFill>
                   <a:srgbClr val="FFFFFF"/>
@@ -5565,6 +5667,7 @@
           <a:lstStyle xmlns:a="http://schemas.openxmlformats.org/drawingml/2006/main"/>
           <a:p xmlns:a="http://schemas.openxmlformats.org/drawingml/2006/main">
             <a:pPr algn="l">
+              <a:buNone/>
               <a:defRPr sz="1350" b="1">
                 <a:solidFill>
                   <a:srgbClr val="101828"/>
@@ -5588,6 +5691,7 @@
           </a:p>
           <a:p xmlns:a="http://schemas.openxmlformats.org/drawingml/2006/main">
             <a:pPr algn="l">
+              <a:buNone/>
               <a:defRPr sz="1350" b="1">
                 <a:solidFill>
                   <a:srgbClr val="101828"/>
@@ -5611,6 +5715,7 @@
           </a:p>
           <a:p xmlns:a="http://schemas.openxmlformats.org/drawingml/2006/main">
             <a:pPr algn="l">
+              <a:buNone/>
               <a:defRPr sz="1350" b="1">
                 <a:solidFill>
                   <a:srgbClr val="101828"/>
@@ -5636,7 +5741,7 @@
       </p:sp>
       <p:cxnSp>
         <p:nvCxnSpPr>
-          <p:cNvPr id="35" name="skills-rule"/>
+          <p:cNvPr id="67" name="skills-rule"/>
           <p:cNvCxnSpPr/>
           <p:nvPr/>
         </p:nvCxnSpPr>
@@ -5691,6 +5796,7 @@
           <a:lstStyle xmlns:a="http://schemas.openxmlformats.org/drawingml/2006/main"/>
           <a:p xmlns:a="http://schemas.openxmlformats.org/drawingml/2006/main">
             <a:pPr algn="ctr">
+              <a:buNone/>
               <a:defRPr sz="1275" b="1">
                 <a:solidFill>
                   <a:srgbClr val="0B3B75"/>
@@ -5749,6 +5855,7 @@
           <a:lstStyle xmlns:a="http://schemas.openxmlformats.org/drawingml/2006/main"/>
           <a:p xmlns:a="http://schemas.openxmlformats.org/drawingml/2006/main">
             <a:pPr algn="l">
+              <a:buNone/>
               <a:defRPr sz="750" b="0">
                 <a:solidFill>
                   <a:srgbClr val="98A2B3"/>
@@ -5807,6 +5914,7 @@
           <a:lstStyle xmlns:a="http://schemas.openxmlformats.org/drawingml/2006/main"/>
           <a:p xmlns:a="http://schemas.openxmlformats.org/drawingml/2006/main">
             <a:pPr algn="r">
+              <a:buNone/>
               <a:defRPr sz="825" b="1">
                 <a:solidFill>
                   <a:srgbClr val="98A2B3"/>
@@ -5894,6 +6002,7 @@
           <a:lstStyle xmlns:a="http://schemas.openxmlformats.org/drawingml/2006/main"/>
           <a:p xmlns:a="http://schemas.openxmlformats.org/drawingml/2006/main">
             <a:pPr algn="l">
+              <a:buNone/>
               <a:defRPr sz="900" b="1">
                 <a:solidFill>
                   <a:srgbClr val="1666D3"/>
@@ -5952,6 +6061,7 @@
           <a:lstStyle xmlns:a="http://schemas.openxmlformats.org/drawingml/2006/main"/>
           <a:p xmlns:a="http://schemas.openxmlformats.org/drawingml/2006/main">
             <a:pPr algn="l">
+              <a:buNone/>
               <a:defRPr sz="2550" b="1">
                 <a:solidFill>
                   <a:srgbClr val="101828"/>
@@ -5977,7 +6087,7 @@
       </p:sp>
       <p:cxnSp>
         <p:nvCxnSpPr>
-          <p:cNvPr id="35" name="header-line-12"/>
+          <p:cNvPr id="41" name="header-line-12"/>
           <p:cNvCxnSpPr/>
           <p:nvPr/>
         </p:nvCxnSpPr>
@@ -6036,6 +6146,7 @@
           <a:lstStyle xmlns:a="http://schemas.openxmlformats.org/drawingml/2006/main"/>
           <a:p xmlns:a="http://schemas.openxmlformats.org/drawingml/2006/main">
             <a:pPr algn="ctr">
+              <a:buNone/>
               <a:defRPr sz="1200" b="1">
                 <a:solidFill>
                   <a:srgbClr val="FFFFFF"/>
@@ -6100,6 +6211,7 @@
           <a:lstStyle xmlns:a="http://schemas.openxmlformats.org/drawingml/2006/main"/>
           <a:p xmlns:a="http://schemas.openxmlformats.org/drawingml/2006/main">
             <a:pPr algn="ctr">
+              <a:buNone/>
               <a:defRPr sz="1200" b="1">
                 <a:solidFill>
                   <a:srgbClr val="1666D3"/>
@@ -6158,6 +6270,7 @@
           <a:lstStyle xmlns:a="http://schemas.openxmlformats.org/drawingml/2006/main"/>
           <a:p xmlns:a="http://schemas.openxmlformats.org/drawingml/2006/main">
             <a:pPr algn="ctr">
+              <a:buNone/>
               <a:defRPr sz="1350" b="1">
                 <a:solidFill>
                   <a:srgbClr val="98A2B3"/>
@@ -6220,6 +6333,7 @@
           <a:lstStyle xmlns:a="http://schemas.openxmlformats.org/drawingml/2006/main"/>
           <a:p xmlns:a="http://schemas.openxmlformats.org/drawingml/2006/main">
             <a:pPr algn="ctr">
+              <a:buNone/>
               <a:defRPr sz="1200" b="1">
                 <a:solidFill>
                   <a:srgbClr val="FFFFFF"/>
@@ -6284,6 +6398,7 @@
           <a:lstStyle xmlns:a="http://schemas.openxmlformats.org/drawingml/2006/main"/>
           <a:p xmlns:a="http://schemas.openxmlformats.org/drawingml/2006/main">
             <a:pPr algn="ctr">
+              <a:buNone/>
               <a:defRPr sz="1200" b="1">
                 <a:solidFill>
                   <a:srgbClr val="1666D3"/>
@@ -6342,6 +6457,7 @@
           <a:lstStyle xmlns:a="http://schemas.openxmlformats.org/drawingml/2006/main"/>
           <a:p xmlns:a="http://schemas.openxmlformats.org/drawingml/2006/main">
             <a:pPr algn="ctr">
+              <a:buNone/>
               <a:defRPr sz="1350" b="1">
                 <a:solidFill>
                   <a:srgbClr val="98A2B3"/>
@@ -6404,6 +6520,7 @@
           <a:lstStyle xmlns:a="http://schemas.openxmlformats.org/drawingml/2006/main"/>
           <a:p xmlns:a="http://schemas.openxmlformats.org/drawingml/2006/main">
             <a:pPr algn="ctr">
+              <a:buNone/>
               <a:defRPr sz="1200" b="1">
                 <a:solidFill>
                   <a:srgbClr val="FFFFFF"/>
@@ -6468,6 +6585,7 @@
           <a:lstStyle xmlns:a="http://schemas.openxmlformats.org/drawingml/2006/main"/>
           <a:p xmlns:a="http://schemas.openxmlformats.org/drawingml/2006/main">
             <a:pPr algn="ctr">
+              <a:buNone/>
               <a:defRPr sz="1200" b="1">
                 <a:solidFill>
                   <a:srgbClr val="1666D3"/>
@@ -6526,6 +6644,7 @@
           <a:lstStyle xmlns:a="http://schemas.openxmlformats.org/drawingml/2006/main"/>
           <a:p xmlns:a="http://schemas.openxmlformats.org/drawingml/2006/main">
             <a:pPr algn="ctr">
+              <a:buNone/>
               <a:defRPr sz="1350" b="1">
                 <a:solidFill>
                   <a:srgbClr val="98A2B3"/>
@@ -6588,6 +6707,7 @@
           <a:lstStyle xmlns:a="http://schemas.openxmlformats.org/drawingml/2006/main"/>
           <a:p xmlns:a="http://schemas.openxmlformats.org/drawingml/2006/main">
             <a:pPr algn="ctr">
+              <a:buNone/>
               <a:defRPr sz="1200" b="1">
                 <a:solidFill>
                   <a:srgbClr val="FFFFFF"/>
@@ -6652,6 +6772,7 @@
           <a:lstStyle xmlns:a="http://schemas.openxmlformats.org/drawingml/2006/main"/>
           <a:p xmlns:a="http://schemas.openxmlformats.org/drawingml/2006/main">
             <a:pPr algn="ctr">
+              <a:buNone/>
               <a:defRPr sz="1200" b="1">
                 <a:solidFill>
                   <a:srgbClr val="1666D3"/>
@@ -6710,6 +6831,7 @@
           <a:lstStyle xmlns:a="http://schemas.openxmlformats.org/drawingml/2006/main"/>
           <a:p xmlns:a="http://schemas.openxmlformats.org/drawingml/2006/main">
             <a:pPr algn="ctr">
+              <a:buNone/>
               <a:defRPr sz="1350" b="1">
                 <a:solidFill>
                   <a:srgbClr val="98A2B3"/>
@@ -6772,6 +6894,7 @@
           <a:lstStyle xmlns:a="http://schemas.openxmlformats.org/drawingml/2006/main"/>
           <a:p xmlns:a="http://schemas.openxmlformats.org/drawingml/2006/main">
             <a:pPr algn="ctr">
+              <a:buNone/>
               <a:defRPr sz="1200" b="1">
                 <a:solidFill>
                   <a:srgbClr val="FFFFFF"/>
@@ -6836,6 +6959,7 @@
           <a:lstStyle xmlns:a="http://schemas.openxmlformats.org/drawingml/2006/main"/>
           <a:p xmlns:a="http://schemas.openxmlformats.org/drawingml/2006/main">
             <a:pPr algn="ctr">
+              <a:buNone/>
               <a:defRPr sz="1200" b="1">
                 <a:solidFill>
                   <a:srgbClr val="C83838"/>
@@ -6894,6 +7018,7 @@
           <a:lstStyle xmlns:a="http://schemas.openxmlformats.org/drawingml/2006/main"/>
           <a:p xmlns:a="http://schemas.openxmlformats.org/drawingml/2006/main">
             <a:pPr algn="ctr">
+              <a:buNone/>
               <a:defRPr sz="1350" b="1">
                 <a:solidFill>
                   <a:srgbClr val="98A2B3"/>
@@ -6956,6 +7081,7 @@
           <a:lstStyle xmlns:a="http://schemas.openxmlformats.org/drawingml/2006/main"/>
           <a:p xmlns:a="http://schemas.openxmlformats.org/drawingml/2006/main">
             <a:pPr algn="ctr">
+              <a:buNone/>
               <a:defRPr sz="1200" b="1">
                 <a:solidFill>
                   <a:srgbClr val="FFFFFF"/>
@@ -7020,6 +7146,7 @@
           <a:lstStyle xmlns:a="http://schemas.openxmlformats.org/drawingml/2006/main"/>
           <a:p xmlns:a="http://schemas.openxmlformats.org/drawingml/2006/main">
             <a:pPr algn="ctr">
+              <a:buNone/>
               <a:defRPr sz="1200" b="1">
                 <a:solidFill>
                   <a:srgbClr val="16865B"/>
@@ -7078,6 +7205,7 @@
           <a:lstStyle xmlns:a="http://schemas.openxmlformats.org/drawingml/2006/main"/>
           <a:p xmlns:a="http://schemas.openxmlformats.org/drawingml/2006/main">
             <a:pPr algn="ctr">
+              <a:buNone/>
               <a:defRPr sz="1350" b="1">
                 <a:solidFill>
                   <a:srgbClr val="98A2B3"/>
@@ -7140,6 +7268,7 @@
           <a:lstStyle xmlns:a="http://schemas.openxmlformats.org/drawingml/2006/main"/>
           <a:p xmlns:a="http://schemas.openxmlformats.org/drawingml/2006/main">
             <a:pPr algn="ctr">
+              <a:buNone/>
               <a:defRPr sz="1200" b="1">
                 <a:solidFill>
                   <a:srgbClr val="FFFFFF"/>
@@ -7204,6 +7333,7 @@
           <a:lstStyle xmlns:a="http://schemas.openxmlformats.org/drawingml/2006/main"/>
           <a:p xmlns:a="http://schemas.openxmlformats.org/drawingml/2006/main">
             <a:pPr algn="ctr">
+              <a:buNone/>
               <a:defRPr sz="1200" b="1">
                 <a:solidFill>
                   <a:srgbClr val="16865B"/>
@@ -7297,6 +7427,7 @@
           <a:lstStyle xmlns:a="http://schemas.openxmlformats.org/drawingml/2006/main"/>
           <a:p xmlns:a="http://schemas.openxmlformats.org/drawingml/2006/main">
             <a:pPr algn="l">
+              <a:buNone/>
               <a:defRPr sz="1650" b="1">
                 <a:solidFill>
                   <a:srgbClr val="C83838"/>
@@ -7355,6 +7486,7 @@
           <a:lstStyle xmlns:a="http://schemas.openxmlformats.org/drawingml/2006/main"/>
           <a:p xmlns:a="http://schemas.openxmlformats.org/drawingml/2006/main">
             <a:pPr algn="ctr">
+              <a:buNone/>
               <a:defRPr sz="1350" b="1">
                 <a:solidFill>
                   <a:srgbClr val="101828"/>
@@ -7419,6 +7551,7 @@
           <a:lstStyle xmlns:a="http://schemas.openxmlformats.org/drawingml/2006/main"/>
           <a:p xmlns:a="http://schemas.openxmlformats.org/drawingml/2006/main">
             <a:pPr algn="ctr">
+              <a:buNone/>
               <a:defRPr sz="1425" b="1">
                 <a:solidFill>
                   <a:srgbClr val="FFFFFF"/>
@@ -7437,7 +7570,7 @@
                 <a:ea typeface="Microsoft YaHei"/>
                 <a:cs typeface="Microsoft YaHei"/>
               </a:rPr>
-              <a:t>离线确定性模式</a:t>
+              <a:t>浏览器确定性链路</a:t>
             </a:r>
           </a:p>
         </p:txBody>
@@ -7477,6 +7610,7 @@
           <a:lstStyle xmlns:a="http://schemas.openxmlformats.org/drawingml/2006/main"/>
           <a:p xmlns:a="http://schemas.openxmlformats.org/drawingml/2006/main">
             <a:pPr algn="l">
+              <a:buNone/>
               <a:defRPr sz="1200" b="1">
                 <a:solidFill>
                   <a:srgbClr val="667085"/>
@@ -7495,7 +7629,7 @@
                 <a:ea typeface="Microsoft YaHei"/>
                 <a:cs typeface="Microsoft YaHei"/>
               </a:rPr>
-              <a:t>保证评审现场可复现</a:t>
+              <a:t>50 项测试，77 / 85 可复现</a:t>
             </a:r>
           </a:p>
         </p:txBody>
@@ -7541,6 +7675,7 @@
           <a:lstStyle xmlns:a="http://schemas.openxmlformats.org/drawingml/2006/main"/>
           <a:p xmlns:a="http://schemas.openxmlformats.org/drawingml/2006/main">
             <a:pPr algn="ctr">
+              <a:buNone/>
               <a:defRPr sz="1425" b="1">
                 <a:solidFill>
                   <a:srgbClr val="1666D3"/>
@@ -7559,7 +7694,7 @@
                 <a:ea typeface="Microsoft YaHei"/>
                 <a:cs typeface="Microsoft YaHei"/>
               </a:rPr>
-              <a:t>在线 AgentTeams 模式</a:t>
+              <a:t>HiClaw Team 实机链路</a:t>
             </a:r>
           </a:p>
         </p:txBody>
@@ -7594,11 +7729,12 @@
         </p:spPr>
         <p:txBody>
           <a:bodyPr xmlns:a="http://schemas.openxmlformats.org/drawingml/2006/main" wrap="square" lIns="76200" tIns="57150" rIns="76200" bIns="57150" anchor="ctr">
-            <a:normAutofit fontScale="100000"/>
+            <a:normAutofit fontScale="84891"/>
           </a:bodyPr>
           <a:lstStyle xmlns:a="http://schemas.openxmlformats.org/drawingml/2006/main"/>
           <a:p xmlns:a="http://schemas.openxmlformats.org/drawingml/2006/main">
             <a:pPr algn="l">
+              <a:buNone/>
               <a:defRPr sz="1200" b="1">
                 <a:solidFill>
                   <a:srgbClr val="667085"/>
@@ -7617,7 +7753,7 @@
                 <a:ea typeface="Microsoft YaHei"/>
                 <a:cs typeface="Microsoft YaHei"/>
               </a:rPr>
-              <a:t>展示真实协作、重试与追踪</a:t>
+              <a:t>6 Worker，5 阶段，状态 READY</a:t>
             </a:r>
           </a:p>
         </p:txBody>
@@ -7657,6 +7793,7 @@
           <a:lstStyle xmlns:a="http://schemas.openxmlformats.org/drawingml/2006/main"/>
           <a:p xmlns:a="http://schemas.openxmlformats.org/drawingml/2006/main">
             <a:pPr algn="l">
+              <a:buNone/>
               <a:defRPr sz="750" b="0">
                 <a:solidFill>
                   <a:srgbClr val="98A2B3"/>
@@ -7675,7 +7812,7 @@
                 <a:ea typeface="Microsoft YaHei"/>
                 <a:cs typeface="Microsoft YaHei"/>
               </a:rPr>
-              <a:t>复杂任务多 Agent 自主协同｜初赛方案</a:t>
+              <a:t>复杂任务多 Agent 自主协同｜本地 MVP 实测</a:t>
             </a:r>
           </a:p>
         </p:txBody>
@@ -7715,6 +7852,7 @@
           <a:lstStyle xmlns:a="http://schemas.openxmlformats.org/drawingml/2006/main"/>
           <a:p xmlns:a="http://schemas.openxmlformats.org/drawingml/2006/main">
             <a:pPr algn="r">
+              <a:buNone/>
               <a:defRPr sz="825" b="1">
                 <a:solidFill>
                   <a:srgbClr val="98A2B3"/>
@@ -7802,6 +7940,7 @@
           <a:lstStyle xmlns:a="http://schemas.openxmlformats.org/drawingml/2006/main"/>
           <a:p xmlns:a="http://schemas.openxmlformats.org/drawingml/2006/main">
             <a:pPr algn="l">
+              <a:buNone/>
               <a:defRPr sz="900" b="1">
                 <a:solidFill>
                   <a:srgbClr val="1666D3"/>
@@ -7860,6 +7999,7 @@
           <a:lstStyle xmlns:a="http://schemas.openxmlformats.org/drawingml/2006/main"/>
           <a:p xmlns:a="http://schemas.openxmlformats.org/drawingml/2006/main">
             <a:pPr algn="l">
+              <a:buNone/>
               <a:defRPr sz="2550" b="1">
                 <a:solidFill>
                   <a:srgbClr val="101828"/>
@@ -7878,14 +8018,14 @@
                 <a:ea typeface="Microsoft YaHei"/>
                 <a:cs typeface="Microsoft YaHei"/>
               </a:rPr>
-              <a:t>用固定数据集验证可靠性，而不是只录成功视频</a:t>
+              <a:t>固定数据 + 实机链路：当前可复现证据</a:t>
             </a:r>
           </a:p>
         </p:txBody>
       </p:sp>
       <p:cxnSp>
         <p:nvCxnSpPr>
-          <p:cNvPr id="28" name="header-line-13"/>
+          <p:cNvPr id="34" name="header-line-13"/>
           <p:cNvCxnSpPr/>
           <p:nvPr/>
         </p:nvCxnSpPr>
@@ -7946,6 +8086,7 @@
           <a:lstStyle xmlns:a="http://schemas.openxmlformats.org/drawingml/2006/main"/>
           <a:p xmlns:a="http://schemas.openxmlformats.org/drawingml/2006/main">
             <a:pPr algn="ctr">
+              <a:buNone/>
               <a:defRPr sz="1050" b="1">
                 <a:solidFill>
                   <a:srgbClr val="C83838"/>
@@ -7964,7 +8105,7 @@
                 <a:ea typeface="Microsoft YaHei"/>
                 <a:cs typeface="Microsoft YaHei"/>
               </a:rPr>
-              <a:t>复赛验收目标｜尚未实测</a:t>
+              <a:t>本地 MVP 实测｜2026-08-14</a:t>
             </a:r>
           </a:p>
         </p:txBody>
@@ -8039,6 +8180,7 @@
           <a:lstStyle xmlns:a="http://schemas.openxmlformats.org/drawingml/2006/main"/>
           <a:p xmlns:a="http://schemas.openxmlformats.org/drawingml/2006/main">
             <a:pPr algn="ctr">
+              <a:buNone/>
               <a:defRPr sz="3000" b="1">
                 <a:solidFill>
                   <a:srgbClr val="1666D3"/>
@@ -8057,7 +8199,7 @@
                 <a:ea typeface="Microsoft YaHei"/>
                 <a:cs typeface="Microsoft YaHei"/>
               </a:rPr>
-              <a:t>100%</a:t>
+              <a:t>50</a:t>
             </a:r>
           </a:p>
         </p:txBody>
@@ -8097,6 +8239,7 @@
           <a:lstStyle xmlns:a="http://schemas.openxmlformats.org/drawingml/2006/main"/>
           <a:p xmlns:a="http://schemas.openxmlformats.org/drawingml/2006/main">
             <a:pPr algn="ctr">
+              <a:buNone/>
               <a:defRPr sz="1275" b="1">
                 <a:solidFill>
                   <a:srgbClr val="101828"/>
@@ -8115,7 +8258,7 @@
                 <a:ea typeface="Microsoft YaHei"/>
                 <a:cs typeface="Microsoft YaHei"/>
               </a:rPr>
-              <a:t>重要结论证据覆盖率</a:t>
+              <a:t>自动化测试全部通过</a:t>
             </a:r>
           </a:p>
         </p:txBody>
@@ -8190,6 +8333,7 @@
           <a:lstStyle xmlns:a="http://schemas.openxmlformats.org/drawingml/2006/main"/>
           <a:p xmlns:a="http://schemas.openxmlformats.org/drawingml/2006/main">
             <a:pPr algn="ctr">
+              <a:buNone/>
               <a:defRPr sz="3000" b="1">
                 <a:solidFill>
                   <a:srgbClr val="C83838"/>
@@ -8208,7 +8352,7 @@
                 <a:ea typeface="Microsoft YaHei"/>
                 <a:cs typeface="Microsoft YaHei"/>
               </a:rPr>
-              <a:t>0%</a:t>
+              <a:t>0</a:t>
             </a:r>
           </a:p>
         </p:txBody>
@@ -8248,6 +8392,7 @@
           <a:lstStyle xmlns:a="http://schemas.openxmlformats.org/drawingml/2006/main"/>
           <a:p xmlns:a="http://schemas.openxmlformats.org/drawingml/2006/main">
             <a:pPr algn="ctr">
+              <a:buNone/>
               <a:defRPr sz="1275" b="1">
                 <a:solidFill>
                   <a:srgbClr val="101828"/>
@@ -8266,7 +8411,7 @@
                 <a:ea typeface="Microsoft YaHei"/>
                 <a:cs typeface="Microsoft YaHei"/>
               </a:rPr>
-              <a:t>虚构经历放行率</a:t>
+              <a:t>浏览器控制台错误</a:t>
             </a:r>
           </a:p>
         </p:txBody>
@@ -8341,6 +8486,7 @@
           <a:lstStyle xmlns:a="http://schemas.openxmlformats.org/drawingml/2006/main"/>
           <a:p xmlns:a="http://schemas.openxmlformats.org/drawingml/2006/main">
             <a:pPr algn="ctr">
+              <a:buNone/>
               <a:defRPr sz="3000" b="1">
                 <a:solidFill>
                   <a:srgbClr val="C83838"/>
@@ -8359,7 +8505,7 @@
                 <a:ea typeface="Microsoft YaHei"/>
                 <a:cs typeface="Microsoft YaHei"/>
               </a:rPr>
-              <a:t>0%</a:t>
+              <a:t>0</a:t>
             </a:r>
           </a:p>
         </p:txBody>
@@ -8399,6 +8545,7 @@
           <a:lstStyle xmlns:a="http://schemas.openxmlformats.org/drawingml/2006/main"/>
           <a:p xmlns:a="http://schemas.openxmlformats.org/drawingml/2006/main">
             <a:pPr algn="ctr">
+              <a:buNone/>
               <a:defRPr sz="1275" b="1">
                 <a:solidFill>
                   <a:srgbClr val="101828"/>
@@ -8417,7 +8564,7 @@
                 <a:ea typeface="Microsoft YaHei"/>
                 <a:cs typeface="Microsoft YaHei"/>
               </a:rPr>
-              <a:t>歧视条件进入评分率</a:t>
+              <a:t>歧视条件进入评分</a:t>
             </a:r>
           </a:p>
         </p:txBody>
@@ -8492,6 +8639,7 @@
           <a:lstStyle xmlns:a="http://schemas.openxmlformats.org/drawingml/2006/main"/>
           <a:p xmlns:a="http://schemas.openxmlformats.org/drawingml/2006/main">
             <a:pPr algn="ctr">
+              <a:buNone/>
               <a:defRPr sz="3000" b="1">
                 <a:solidFill>
                   <a:srgbClr val="16865B"/>
@@ -8510,7 +8658,7 @@
                 <a:ea typeface="Microsoft YaHei"/>
                 <a:cs typeface="Microsoft YaHei"/>
               </a:rPr>
-              <a:t>≥90%</a:t>
+              <a:t>6 / 6</a:t>
             </a:r>
           </a:p>
         </p:txBody>
@@ -8550,6 +8698,7 @@
           <a:lstStyle xmlns:a="http://schemas.openxmlformats.org/drawingml/2006/main"/>
           <a:p xmlns:a="http://schemas.openxmlformats.org/drawingml/2006/main">
             <a:pPr algn="ctr">
+              <a:buNone/>
               <a:defRPr sz="1275" b="1">
                 <a:solidFill>
                   <a:srgbClr val="101828"/>
@@ -8568,7 +8717,7 @@
                 <a:ea typeface="Microsoft YaHei"/>
                 <a:cs typeface="Microsoft YaHei"/>
               </a:rPr>
-              <a:t>完整任务成功率</a:t>
+              <a:t>Worker MCP 健康</a:t>
             </a:r>
           </a:p>
         </p:txBody>
@@ -8643,6 +8792,7 @@
           <a:lstStyle xmlns:a="http://schemas.openxmlformats.org/drawingml/2006/main"/>
           <a:p xmlns:a="http://schemas.openxmlformats.org/drawingml/2006/main">
             <a:pPr algn="ctr">
+              <a:buNone/>
               <a:defRPr sz="3000" b="1">
                 <a:solidFill>
                   <a:srgbClr val="16865B"/>
@@ -8661,7 +8811,7 @@
                 <a:ea typeface="Microsoft YaHei"/>
                 <a:cs typeface="Microsoft YaHei"/>
               </a:rPr>
-              <a:t>≥95%</a:t>
+              <a:t>5 / 5</a:t>
             </a:r>
           </a:p>
         </p:txBody>
@@ -8701,6 +8851,7 @@
           <a:lstStyle xmlns:a="http://schemas.openxmlformats.org/drawingml/2006/main"/>
           <a:p xmlns:a="http://schemas.openxmlformats.org/drawingml/2006/main">
             <a:pPr algn="ctr">
+              <a:buNone/>
               <a:defRPr sz="1275" b="1">
                 <a:solidFill>
                   <a:srgbClr val="101828"/>
@@ -8719,7 +8870,7 @@
                 <a:ea typeface="Microsoft YaHei"/>
                 <a:cs typeface="Microsoft YaHei"/>
               </a:rPr>
-              <a:t>Tool 调用成功率</a:t>
+              <a:t>Team 专业阶段完成</a:t>
             </a:r>
           </a:p>
         </p:txBody>
@@ -8794,6 +8945,7 @@
           <a:lstStyle xmlns:a="http://schemas.openxmlformats.org/drawingml/2006/main"/>
           <a:p xmlns:a="http://schemas.openxmlformats.org/drawingml/2006/main">
             <a:pPr algn="ctr">
+              <a:buNone/>
               <a:defRPr sz="3000" b="1">
                 <a:solidFill>
                   <a:srgbClr val="1666D3"/>
@@ -8812,7 +8964,7 @@
                 <a:ea typeface="Microsoft YaHei"/>
                 <a:cs typeface="Microsoft YaHei"/>
               </a:rPr>
-              <a:t>100%</a:t>
+              <a:t>READY</a:t>
             </a:r>
           </a:p>
         </p:txBody>
@@ -8852,6 +9004,7 @@
           <a:lstStyle xmlns:a="http://schemas.openxmlformats.org/drawingml/2006/main"/>
           <a:p xmlns:a="http://schemas.openxmlformats.org/drawingml/2006/main">
             <a:pPr algn="ctr">
+              <a:buNone/>
               <a:defRPr sz="1275" b="1">
                 <a:solidFill>
                   <a:srgbClr val="101828"/>
@@ -8870,7 +9023,7 @@
                 <a:ea typeface="Microsoft YaHei"/>
                 <a:cs typeface="Microsoft YaHei"/>
               </a:rPr>
-              <a:t>导出审批覆盖率</a:t>
+              <a:t>最终业务状态</a:t>
             </a:r>
           </a:p>
         </p:txBody>
@@ -8910,6 +9063,7 @@
           <a:lstStyle xmlns:a="http://schemas.openxmlformats.org/drawingml/2006/main"/>
           <a:p xmlns:a="http://schemas.openxmlformats.org/drawingml/2006/main">
             <a:pPr algn="ctr">
+              <a:buNone/>
               <a:defRPr sz="1275" b="1">
                 <a:solidFill>
                   <a:srgbClr val="0B3B75"/>
@@ -8928,7 +9082,7 @@
                 <a:ea typeface="Microsoft YaHei"/>
                 <a:cs typeface="Microsoft YaHei"/>
               </a:rPr>
-              <a:t>固定合成数据集 + 正常用例 + 缺证用例 + 工具失败用例 + 歧视条件用例 + 危机信号用例</a:t>
+              <a:t>浏览器桌面/移动端 + API + MCP + Worker Skills + Team Room + 共享结果</a:t>
             </a:r>
           </a:p>
         </p:txBody>
@@ -8968,6 +9122,7 @@
           <a:lstStyle xmlns:a="http://schemas.openxmlformats.org/drawingml/2006/main"/>
           <a:p xmlns:a="http://schemas.openxmlformats.org/drawingml/2006/main">
             <a:pPr algn="l">
+              <a:buNone/>
               <a:defRPr sz="750" b="0">
                 <a:solidFill>
                   <a:srgbClr val="98A2B3"/>
@@ -8986,7 +9141,7 @@
                 <a:ea typeface="Microsoft YaHei"/>
                 <a:cs typeface="Microsoft YaHei"/>
               </a:rPr>
-              <a:t>复杂任务多 Agent 自主协同｜目标值，尚未实测</a:t>
+              <a:t>复杂任务多 Agent 自主协同｜实机记录见 show/19</a:t>
             </a:r>
           </a:p>
         </p:txBody>
@@ -9026,6 +9181,7 @@
           <a:lstStyle xmlns:a="http://schemas.openxmlformats.org/drawingml/2006/main"/>
           <a:p xmlns:a="http://schemas.openxmlformats.org/drawingml/2006/main">
             <a:pPr algn="r">
+              <a:buNone/>
               <a:defRPr sz="825" b="1">
                 <a:solidFill>
                   <a:srgbClr val="98A2B3"/>
@@ -9113,6 +9269,7 @@
           <a:lstStyle xmlns:a="http://schemas.openxmlformats.org/drawingml/2006/main"/>
           <a:p xmlns:a="http://schemas.openxmlformats.org/drawingml/2006/main">
             <a:pPr algn="l">
+              <a:buNone/>
               <a:defRPr sz="900" b="1">
                 <a:solidFill>
                   <a:srgbClr val="1666D3"/>
@@ -9171,6 +9328,7 @@
           <a:lstStyle xmlns:a="http://schemas.openxmlformats.org/drawingml/2006/main"/>
           <a:p xmlns:a="http://schemas.openxmlformats.org/drawingml/2006/main">
             <a:pPr algn="l">
+              <a:buNone/>
               <a:defRPr sz="2550" b="1">
                 <a:solidFill>
                   <a:srgbClr val="101828"/>
@@ -9196,7 +9354,7 @@
       </p:sp>
       <p:cxnSp>
         <p:nvCxnSpPr>
-          <p:cNvPr id="29" name="header-line-14"/>
+          <p:cNvPr id="35" name="header-line-14"/>
           <p:cNvCxnSpPr/>
           <p:nvPr/>
         </p:nvCxnSpPr>
@@ -9251,6 +9409,7 @@
           <a:lstStyle xmlns:a="http://schemas.openxmlformats.org/drawingml/2006/main"/>
           <a:p xmlns:a="http://schemas.openxmlformats.org/drawingml/2006/main">
             <a:pPr algn="ctr">
+              <a:buNone/>
               <a:defRPr sz="975" b="1">
                 <a:solidFill>
                   <a:srgbClr val="1666D3"/>
@@ -9344,6 +9503,7 @@
           <a:lstStyle xmlns:a="http://schemas.openxmlformats.org/drawingml/2006/main"/>
           <a:p xmlns:a="http://schemas.openxmlformats.org/drawingml/2006/main">
             <a:pPr algn="ctr">
+              <a:buNone/>
               <a:defRPr sz="1800" b="1">
                 <a:solidFill>
                   <a:srgbClr val="0B3B75"/>
@@ -9402,6 +9562,7 @@
           <a:lstStyle xmlns:a="http://schemas.openxmlformats.org/drawingml/2006/main"/>
           <a:p xmlns:a="http://schemas.openxmlformats.org/drawingml/2006/main">
             <a:pPr algn="ctr">
+              <a:buNone/>
               <a:defRPr sz="1200" b="1">
                 <a:solidFill>
                   <a:srgbClr val="667085"/>
@@ -9460,6 +9621,7 @@
           <a:lstStyle xmlns:a="http://schemas.openxmlformats.org/drawingml/2006/main"/>
           <a:p xmlns:a="http://schemas.openxmlformats.org/drawingml/2006/main">
             <a:pPr algn="ctr">
+              <a:buNone/>
               <a:defRPr sz="975" b="1">
                 <a:solidFill>
                   <a:srgbClr val="1666D3"/>
@@ -9553,6 +9715,7 @@
           <a:lstStyle xmlns:a="http://schemas.openxmlformats.org/drawingml/2006/main"/>
           <a:p xmlns:a="http://schemas.openxmlformats.org/drawingml/2006/main">
             <a:pPr algn="ctr">
+              <a:buNone/>
               <a:defRPr sz="1800" b="1">
                 <a:solidFill>
                   <a:srgbClr val="0B3B75"/>
@@ -9611,6 +9774,7 @@
           <a:lstStyle xmlns:a="http://schemas.openxmlformats.org/drawingml/2006/main"/>
           <a:p xmlns:a="http://schemas.openxmlformats.org/drawingml/2006/main">
             <a:pPr algn="ctr">
+              <a:buNone/>
               <a:defRPr sz="1200" b="1">
                 <a:solidFill>
                   <a:srgbClr val="667085"/>
@@ -9669,6 +9833,7 @@
           <a:lstStyle xmlns:a="http://schemas.openxmlformats.org/drawingml/2006/main"/>
           <a:p xmlns:a="http://schemas.openxmlformats.org/drawingml/2006/main">
             <a:pPr algn="ctr">
+              <a:buNone/>
               <a:defRPr sz="975" b="1">
                 <a:solidFill>
                   <a:srgbClr val="1666D3"/>
@@ -9762,6 +9927,7 @@
           <a:lstStyle xmlns:a="http://schemas.openxmlformats.org/drawingml/2006/main"/>
           <a:p xmlns:a="http://schemas.openxmlformats.org/drawingml/2006/main">
             <a:pPr algn="ctr">
+              <a:buNone/>
               <a:defRPr sz="1800" b="1">
                 <a:solidFill>
                   <a:srgbClr val="0B3B75"/>
@@ -9820,6 +9986,7 @@
           <a:lstStyle xmlns:a="http://schemas.openxmlformats.org/drawingml/2006/main"/>
           <a:p xmlns:a="http://schemas.openxmlformats.org/drawingml/2006/main">
             <a:pPr algn="ctr">
+              <a:buNone/>
               <a:defRPr sz="1200" b="1">
                 <a:solidFill>
                   <a:srgbClr val="667085"/>
@@ -9878,6 +10045,7 @@
           <a:lstStyle xmlns:a="http://schemas.openxmlformats.org/drawingml/2006/main"/>
           <a:p xmlns:a="http://schemas.openxmlformats.org/drawingml/2006/main">
             <a:pPr algn="ctr">
+              <a:buNone/>
               <a:defRPr sz="975" b="1">
                 <a:solidFill>
                   <a:srgbClr val="1666D3"/>
@@ -9971,6 +10139,7 @@
           <a:lstStyle xmlns:a="http://schemas.openxmlformats.org/drawingml/2006/main"/>
           <a:p xmlns:a="http://schemas.openxmlformats.org/drawingml/2006/main">
             <a:pPr algn="ctr">
+              <a:buNone/>
               <a:defRPr sz="1800" b="1">
                 <a:solidFill>
                   <a:srgbClr val="0B3B75"/>
@@ -10029,6 +10198,7 @@
           <a:lstStyle xmlns:a="http://schemas.openxmlformats.org/drawingml/2006/main"/>
           <a:p xmlns:a="http://schemas.openxmlformats.org/drawingml/2006/main">
             <a:pPr algn="ctr">
+              <a:buNone/>
               <a:defRPr sz="1200" b="1">
                 <a:solidFill>
                   <a:srgbClr val="667085"/>
@@ -10087,6 +10257,7 @@
           <a:lstStyle xmlns:a="http://schemas.openxmlformats.org/drawingml/2006/main"/>
           <a:p xmlns:a="http://schemas.openxmlformats.org/drawingml/2006/main">
             <a:pPr algn="ctr">
+              <a:buNone/>
               <a:defRPr sz="2100" b="1">
                 <a:solidFill>
                   <a:srgbClr val="101828"/>
@@ -10110,6 +10281,7 @@
           </a:p>
           <a:p xmlns:a="http://schemas.openxmlformats.org/drawingml/2006/main">
             <a:pPr algn="ctr">
+              <a:buNone/>
               <a:defRPr sz="2100" b="1">
                 <a:solidFill>
                   <a:srgbClr val="101828"/>
@@ -10174,6 +10346,7 @@
           <a:lstStyle xmlns:a="http://schemas.openxmlformats.org/drawingml/2006/main"/>
           <a:p xmlns:a="http://schemas.openxmlformats.org/drawingml/2006/main">
             <a:pPr algn="ctr">
+              <a:buNone/>
               <a:defRPr sz="1050" b="1">
                 <a:solidFill>
                   <a:srgbClr val="1666D3"/>
@@ -10238,6 +10411,7 @@
           <a:lstStyle xmlns:a="http://schemas.openxmlformats.org/drawingml/2006/main"/>
           <a:p xmlns:a="http://schemas.openxmlformats.org/drawingml/2006/main">
             <a:pPr algn="ctr">
+              <a:buNone/>
               <a:defRPr sz="1050" b="1">
                 <a:solidFill>
                   <a:srgbClr val="7047B8"/>
@@ -10302,6 +10476,7 @@
           <a:lstStyle xmlns:a="http://schemas.openxmlformats.org/drawingml/2006/main"/>
           <a:p xmlns:a="http://schemas.openxmlformats.org/drawingml/2006/main">
             <a:pPr algn="ctr">
+              <a:buNone/>
               <a:defRPr sz="1050" b="1">
                 <a:solidFill>
                   <a:srgbClr val="16865B"/>
@@ -10366,6 +10541,7 @@
           <a:lstStyle xmlns:a="http://schemas.openxmlformats.org/drawingml/2006/main"/>
           <a:p xmlns:a="http://schemas.openxmlformats.org/drawingml/2006/main">
             <a:pPr algn="ctr">
+              <a:buNone/>
               <a:defRPr sz="1050" b="1">
                 <a:solidFill>
                   <a:srgbClr val="FFFFFF"/>
@@ -10424,6 +10600,7 @@
           <a:lstStyle xmlns:a="http://schemas.openxmlformats.org/drawingml/2006/main"/>
           <a:p xmlns:a="http://schemas.openxmlformats.org/drawingml/2006/main">
             <a:pPr algn="l">
+              <a:buNone/>
               <a:defRPr sz="750" b="0">
                 <a:solidFill>
                   <a:srgbClr val="98A2B3"/>
@@ -10482,6 +10659,7 @@
           <a:lstStyle xmlns:a="http://schemas.openxmlformats.org/drawingml/2006/main"/>
           <a:p xmlns:a="http://schemas.openxmlformats.org/drawingml/2006/main">
             <a:pPr algn="r">
+              <a:buNone/>
               <a:defRPr sz="825" b="1">
                 <a:solidFill>
                   <a:srgbClr val="98A2B3"/>
@@ -10569,6 +10747,7 @@
           <a:lstStyle xmlns:a="http://schemas.openxmlformats.org/drawingml/2006/main"/>
           <a:p xmlns:a="http://schemas.openxmlformats.org/drawingml/2006/main">
             <a:pPr algn="l">
+              <a:buNone/>
               <a:defRPr sz="900" b="1">
                 <a:solidFill>
                   <a:srgbClr val="1666D3"/>
@@ -10627,6 +10806,7 @@
           <a:lstStyle xmlns:a="http://schemas.openxmlformats.org/drawingml/2006/main"/>
           <a:p xmlns:a="http://schemas.openxmlformats.org/drawingml/2006/main">
             <a:pPr algn="l">
+              <a:buNone/>
               <a:defRPr sz="2550" b="1">
                 <a:solidFill>
                   <a:srgbClr val="101828"/>
@@ -10652,7 +10832,7 @@
       </p:sp>
       <p:cxnSp>
         <p:nvCxnSpPr>
-          <p:cNvPr id="27" name="header-line-2"/>
+          <p:cNvPr id="61" name="header-line-2"/>
           <p:cNvCxnSpPr/>
           <p:nvPr/>
         </p:nvCxnSpPr>
@@ -10742,6 +10922,7 @@
           <a:lstStyle xmlns:a="http://schemas.openxmlformats.org/drawingml/2006/main"/>
           <a:p xmlns:a="http://schemas.openxmlformats.org/drawingml/2006/main">
             <a:pPr algn="ctr">
+              <a:buNone/>
               <a:defRPr sz="1275" b="1">
                 <a:solidFill>
                   <a:srgbClr val="D9E9FF"/>
@@ -10800,6 +10981,7 @@
           <a:lstStyle xmlns:a="http://schemas.openxmlformats.org/drawingml/2006/main"/>
           <a:p xmlns:a="http://schemas.openxmlformats.org/drawingml/2006/main">
             <a:pPr algn="ctr">
+              <a:buNone/>
               <a:defRPr sz="5700" b="1">
                 <a:solidFill>
                   <a:srgbClr val="FFFFFF"/>
@@ -10858,6 +11040,7 @@
           <a:lstStyle xmlns:a="http://schemas.openxmlformats.org/drawingml/2006/main"/>
           <a:p xmlns:a="http://schemas.openxmlformats.org/drawingml/2006/main">
             <a:pPr algn="ctr">
+              <a:buNone/>
               <a:defRPr sz="1650" b="1">
                 <a:solidFill>
                   <a:srgbClr val="FFFFFF"/>
@@ -10883,7 +11066,7 @@
       </p:sp>
       <p:cxnSp>
         <p:nvCxnSpPr>
-          <p:cNvPr id="32" name="scale-rule"/>
+          <p:cNvPr id="66" name="scale-rule"/>
           <p:cNvCxnSpPr/>
           <p:nvPr/>
         </p:nvCxnSpPr>
@@ -10938,6 +11121,7 @@
           <a:lstStyle xmlns:a="http://schemas.openxmlformats.org/drawingml/2006/main"/>
           <a:p xmlns:a="http://schemas.openxmlformats.org/drawingml/2006/main">
             <a:pPr algn="ctr">
+              <a:buNone/>
               <a:defRPr sz="1350" b="0">
                 <a:solidFill>
                   <a:srgbClr val="D9E9FF"/>
@@ -10961,6 +11145,7 @@
           </a:p>
           <a:p xmlns:a="http://schemas.openxmlformats.org/drawingml/2006/main">
             <a:pPr algn="ctr">
+              <a:buNone/>
               <a:defRPr sz="1350" b="0">
                 <a:solidFill>
                   <a:srgbClr val="D9E9FF"/>
@@ -11019,6 +11204,7 @@
           <a:lstStyle xmlns:a="http://schemas.openxmlformats.org/drawingml/2006/main"/>
           <a:p xmlns:a="http://schemas.openxmlformats.org/drawingml/2006/main">
             <a:pPr algn="l">
+              <a:buNone/>
               <a:defRPr sz="1200" b="1">
                 <a:solidFill>
                   <a:srgbClr val="1666D3"/>
@@ -11077,6 +11263,7 @@
           <a:lstStyle xmlns:a="http://schemas.openxmlformats.org/drawingml/2006/main"/>
           <a:p xmlns:a="http://schemas.openxmlformats.org/drawingml/2006/main">
             <a:pPr algn="l">
+              <a:buNone/>
               <a:defRPr sz="1800" b="1">
                 <a:solidFill>
                   <a:srgbClr val="101828"/>
@@ -11135,6 +11322,7 @@
           <a:lstStyle xmlns:a="http://schemas.openxmlformats.org/drawingml/2006/main"/>
           <a:p xmlns:a="http://schemas.openxmlformats.org/drawingml/2006/main">
             <a:pPr algn="l">
+              <a:buNone/>
               <a:defRPr sz="1275" b="0">
                 <a:solidFill>
                   <a:srgbClr val="667085"/>
@@ -11160,7 +11348,7 @@
       </p:sp>
       <p:cxnSp>
         <p:nvCxnSpPr>
-          <p:cNvPr id="37" name="ctx-line-0"/>
+          <p:cNvPr id="71" name="ctx-line-0"/>
           <p:cNvCxnSpPr/>
           <p:nvPr/>
         </p:nvCxnSpPr>
@@ -11215,6 +11403,7 @@
           <a:lstStyle xmlns:a="http://schemas.openxmlformats.org/drawingml/2006/main"/>
           <a:p xmlns:a="http://schemas.openxmlformats.org/drawingml/2006/main">
             <a:pPr algn="l">
+              <a:buNone/>
               <a:defRPr sz="1200" b="1">
                 <a:solidFill>
                   <a:srgbClr val="1666D3"/>
@@ -11273,6 +11462,7 @@
           <a:lstStyle xmlns:a="http://schemas.openxmlformats.org/drawingml/2006/main"/>
           <a:p xmlns:a="http://schemas.openxmlformats.org/drawingml/2006/main">
             <a:pPr algn="l">
+              <a:buNone/>
               <a:defRPr sz="1800" b="1">
                 <a:solidFill>
                   <a:srgbClr val="101828"/>
@@ -11331,6 +11521,7 @@
           <a:lstStyle xmlns:a="http://schemas.openxmlformats.org/drawingml/2006/main"/>
           <a:p xmlns:a="http://schemas.openxmlformats.org/drawingml/2006/main">
             <a:pPr algn="l">
+              <a:buNone/>
               <a:defRPr sz="1275" b="0">
                 <a:solidFill>
                   <a:srgbClr val="667085"/>
@@ -11356,7 +11547,7 @@
       </p:sp>
       <p:cxnSp>
         <p:nvCxnSpPr>
-          <p:cNvPr id="41" name="ctx-line-1"/>
+          <p:cNvPr id="75" name="ctx-line-1"/>
           <p:cNvCxnSpPr/>
           <p:nvPr/>
         </p:nvCxnSpPr>
@@ -11411,6 +11602,7 @@
           <a:lstStyle xmlns:a="http://schemas.openxmlformats.org/drawingml/2006/main"/>
           <a:p xmlns:a="http://schemas.openxmlformats.org/drawingml/2006/main">
             <a:pPr algn="l">
+              <a:buNone/>
               <a:defRPr sz="1200" b="1">
                 <a:solidFill>
                   <a:srgbClr val="1666D3"/>
@@ -11469,6 +11661,7 @@
           <a:lstStyle xmlns:a="http://schemas.openxmlformats.org/drawingml/2006/main"/>
           <a:p xmlns:a="http://schemas.openxmlformats.org/drawingml/2006/main">
             <a:pPr algn="l">
+              <a:buNone/>
               <a:defRPr sz="1800" b="1">
                 <a:solidFill>
                   <a:srgbClr val="101828"/>
@@ -11527,6 +11720,7 @@
           <a:lstStyle xmlns:a="http://schemas.openxmlformats.org/drawingml/2006/main"/>
           <a:p xmlns:a="http://schemas.openxmlformats.org/drawingml/2006/main">
             <a:pPr algn="l">
+              <a:buNone/>
               <a:defRPr sz="1275" b="0">
                 <a:solidFill>
                   <a:srgbClr val="667085"/>
@@ -11591,6 +11785,7 @@
           <a:lstStyle xmlns:a="http://schemas.openxmlformats.org/drawingml/2006/main"/>
           <a:p xmlns:a="http://schemas.openxmlformats.org/drawingml/2006/main">
             <a:pPr algn="ctr">
+              <a:buNone/>
               <a:defRPr sz="1050" b="1">
                 <a:solidFill>
                   <a:srgbClr val="1666D3"/>
@@ -11649,6 +11844,7 @@
           <a:lstStyle xmlns:a="http://schemas.openxmlformats.org/drawingml/2006/main"/>
           <a:p xmlns:a="http://schemas.openxmlformats.org/drawingml/2006/main">
             <a:pPr algn="r">
+              <a:buNone/>
               <a:defRPr sz="825" b="0">
                 <a:solidFill>
                   <a:srgbClr val="98A2B3"/>
@@ -11707,6 +11903,7 @@
           <a:lstStyle xmlns:a="http://schemas.openxmlformats.org/drawingml/2006/main"/>
           <a:p xmlns:a="http://schemas.openxmlformats.org/drawingml/2006/main">
             <a:pPr algn="l">
+              <a:buNone/>
               <a:defRPr sz="750" b="0">
                 <a:solidFill>
                   <a:srgbClr val="98A2B3"/>
@@ -11765,6 +11962,7 @@
           <a:lstStyle xmlns:a="http://schemas.openxmlformats.org/drawingml/2006/main"/>
           <a:p xmlns:a="http://schemas.openxmlformats.org/drawingml/2006/main">
             <a:pPr algn="r">
+              <a:buNone/>
               <a:defRPr sz="825" b="1">
                 <a:solidFill>
                   <a:srgbClr val="98A2B3"/>
@@ -11852,6 +12050,7 @@
           <a:lstStyle xmlns:a="http://schemas.openxmlformats.org/drawingml/2006/main"/>
           <a:p xmlns:a="http://schemas.openxmlformats.org/drawingml/2006/main">
             <a:pPr algn="l">
+              <a:buNone/>
               <a:defRPr sz="900" b="1">
                 <a:solidFill>
                   <a:srgbClr val="1666D3"/>
@@ -11910,6 +12109,7 @@
           <a:lstStyle xmlns:a="http://schemas.openxmlformats.org/drawingml/2006/main"/>
           <a:p xmlns:a="http://schemas.openxmlformats.org/drawingml/2006/main">
             <a:pPr algn="l">
+              <a:buNone/>
               <a:defRPr sz="2550" b="1">
                 <a:solidFill>
                   <a:srgbClr val="101828"/>
@@ -11935,7 +12135,7 @@
       </p:sp>
       <p:cxnSp>
         <p:nvCxnSpPr>
-          <p:cNvPr id="29" name="header-line-3"/>
+          <p:cNvPr id="75" name="header-line-3"/>
           <p:cNvCxnSpPr/>
           <p:nvPr/>
         </p:nvCxnSpPr>
@@ -12029,6 +12229,7 @@
           <a:lstStyle xmlns:a="http://schemas.openxmlformats.org/drawingml/2006/main"/>
           <a:p xmlns:a="http://schemas.openxmlformats.org/drawingml/2006/main">
             <a:pPr algn="ctr">
+              <a:buNone/>
               <a:defRPr sz="1350" b="1">
                 <a:solidFill>
                   <a:srgbClr val="FFFFFF"/>
@@ -12087,6 +12288,7 @@
           <a:lstStyle xmlns:a="http://schemas.openxmlformats.org/drawingml/2006/main"/>
           <a:p xmlns:a="http://schemas.openxmlformats.org/drawingml/2006/main">
             <a:pPr algn="l">
+              <a:buNone/>
               <a:defRPr sz="1575" b="1">
                 <a:solidFill>
                   <a:srgbClr val="101828"/>
@@ -12145,6 +12347,7 @@
           <a:lstStyle xmlns:a="http://schemas.openxmlformats.org/drawingml/2006/main"/>
           <a:p xmlns:a="http://schemas.openxmlformats.org/drawingml/2006/main">
             <a:pPr algn="ctr">
+              <a:buNone/>
               <a:defRPr sz="1275" b="1">
                 <a:solidFill>
                   <a:srgbClr val="1666D3"/>
@@ -12203,6 +12406,7 @@
           <a:lstStyle xmlns:a="http://schemas.openxmlformats.org/drawingml/2006/main"/>
           <a:p xmlns:a="http://schemas.openxmlformats.org/drawingml/2006/main">
             <a:pPr algn="ctr">
+              <a:buNone/>
               <a:defRPr sz="2100" b="1">
                 <a:solidFill>
                   <a:srgbClr val="98A2B3"/>
@@ -12300,6 +12504,7 @@
           <a:lstStyle xmlns:a="http://schemas.openxmlformats.org/drawingml/2006/main"/>
           <a:p xmlns:a="http://schemas.openxmlformats.org/drawingml/2006/main">
             <a:pPr algn="ctr">
+              <a:buNone/>
               <a:defRPr sz="1350" b="1">
                 <a:solidFill>
                   <a:srgbClr val="FFFFFF"/>
@@ -12358,6 +12563,7 @@
           <a:lstStyle xmlns:a="http://schemas.openxmlformats.org/drawingml/2006/main"/>
           <a:p xmlns:a="http://schemas.openxmlformats.org/drawingml/2006/main">
             <a:pPr algn="l">
+              <a:buNone/>
               <a:defRPr sz="1575" b="1">
                 <a:solidFill>
                   <a:srgbClr val="101828"/>
@@ -12416,6 +12622,7 @@
           <a:lstStyle xmlns:a="http://schemas.openxmlformats.org/drawingml/2006/main"/>
           <a:p xmlns:a="http://schemas.openxmlformats.org/drawingml/2006/main">
             <a:pPr algn="ctr">
+              <a:buNone/>
               <a:defRPr sz="1275" b="1">
                 <a:solidFill>
                   <a:srgbClr val="C77800"/>
@@ -12474,6 +12681,7 @@
           <a:lstStyle xmlns:a="http://schemas.openxmlformats.org/drawingml/2006/main"/>
           <a:p xmlns:a="http://schemas.openxmlformats.org/drawingml/2006/main">
             <a:pPr algn="ctr">
+              <a:buNone/>
               <a:defRPr sz="2100" b="1">
                 <a:solidFill>
                   <a:srgbClr val="98A2B3"/>
@@ -12571,6 +12779,7 @@
           <a:lstStyle xmlns:a="http://schemas.openxmlformats.org/drawingml/2006/main"/>
           <a:p xmlns:a="http://schemas.openxmlformats.org/drawingml/2006/main">
             <a:pPr algn="ctr">
+              <a:buNone/>
               <a:defRPr sz="1350" b="1">
                 <a:solidFill>
                   <a:srgbClr val="FFFFFF"/>
@@ -12629,6 +12838,7 @@
           <a:lstStyle xmlns:a="http://schemas.openxmlformats.org/drawingml/2006/main"/>
           <a:p xmlns:a="http://schemas.openxmlformats.org/drawingml/2006/main">
             <a:pPr algn="l">
+              <a:buNone/>
               <a:defRPr sz="1575" b="1">
                 <a:solidFill>
                   <a:srgbClr val="101828"/>
@@ -12687,6 +12897,7 @@
           <a:lstStyle xmlns:a="http://schemas.openxmlformats.org/drawingml/2006/main"/>
           <a:p xmlns:a="http://schemas.openxmlformats.org/drawingml/2006/main">
             <a:pPr algn="ctr">
+              <a:buNone/>
               <a:defRPr sz="1275" b="1">
                 <a:solidFill>
                   <a:srgbClr val="C83838"/>
@@ -12745,6 +12956,7 @@
           <a:lstStyle xmlns:a="http://schemas.openxmlformats.org/drawingml/2006/main"/>
           <a:p xmlns:a="http://schemas.openxmlformats.org/drawingml/2006/main">
             <a:pPr algn="ctr">
+              <a:buNone/>
               <a:defRPr sz="2700" b="1">
                 <a:solidFill>
                   <a:srgbClr val="98A2B3"/>
@@ -12809,6 +13021,7 @@
           <a:lstStyle xmlns:a="http://schemas.openxmlformats.org/drawingml/2006/main"/>
           <a:p xmlns:a="http://schemas.openxmlformats.org/drawingml/2006/main">
             <a:pPr algn="ctr">
+              <a:buNone/>
               <a:defRPr sz="4350" b="1">
                 <a:solidFill>
                   <a:srgbClr val="FFFFFF"/>
@@ -12867,6 +13080,7 @@
           <a:lstStyle xmlns:a="http://schemas.openxmlformats.org/drawingml/2006/main"/>
           <a:p xmlns:a="http://schemas.openxmlformats.org/drawingml/2006/main">
             <a:pPr algn="ctr">
+              <a:buNone/>
               <a:defRPr sz="975" b="1">
                 <a:solidFill>
                   <a:srgbClr val="D0D5DD"/>
@@ -12960,6 +13174,7 @@
           <a:lstStyle xmlns:a="http://schemas.openxmlformats.org/drawingml/2006/main"/>
           <a:p xmlns:a="http://schemas.openxmlformats.org/drawingml/2006/main">
             <a:pPr algn="l">
+              <a:buNone/>
               <a:defRPr sz="2325" b="1">
                 <a:solidFill>
                   <a:srgbClr val="0B3B75"/>
@@ -12985,7 +13200,7 @@
       </p:sp>
       <p:cxnSp>
         <p:nvCxnSpPr>
-          <p:cNvPr id="49" name="principle-divider"/>
+          <p:cNvPr id="95" name="principle-divider"/>
           <p:cNvCxnSpPr/>
           <p:nvPr/>
         </p:nvCxnSpPr>
@@ -13040,6 +13255,7 @@
           <a:lstStyle xmlns:a="http://schemas.openxmlformats.org/drawingml/2006/main"/>
           <a:p xmlns:a="http://schemas.openxmlformats.org/drawingml/2006/main">
             <a:pPr algn="l">
+              <a:buNone/>
               <a:defRPr sz="1575" b="1">
                 <a:solidFill>
                   <a:srgbClr val="101828"/>
@@ -13063,6 +13279,7 @@
           </a:p>
           <a:p xmlns:a="http://schemas.openxmlformats.org/drawingml/2006/main">
             <a:pPr algn="l">
+              <a:buNone/>
               <a:defRPr sz="1575" b="1">
                 <a:solidFill>
                   <a:srgbClr val="101828"/>
@@ -13086,6 +13303,7 @@
           </a:p>
           <a:p xmlns:a="http://schemas.openxmlformats.org/drawingml/2006/main">
             <a:pPr algn="l">
+              <a:buNone/>
               <a:defRPr sz="1575" b="1">
                 <a:solidFill>
                   <a:srgbClr val="101828"/>
@@ -13144,6 +13362,7 @@
           <a:lstStyle xmlns:a="http://schemas.openxmlformats.org/drawingml/2006/main"/>
           <a:p xmlns:a="http://schemas.openxmlformats.org/drawingml/2006/main">
             <a:pPr algn="l">
+              <a:buNone/>
               <a:defRPr sz="750" b="0">
                 <a:solidFill>
                   <a:srgbClr val="98A2B3"/>
@@ -13202,6 +13421,7 @@
           <a:lstStyle xmlns:a="http://schemas.openxmlformats.org/drawingml/2006/main"/>
           <a:p xmlns:a="http://schemas.openxmlformats.org/drawingml/2006/main">
             <a:pPr algn="r">
+              <a:buNone/>
               <a:defRPr sz="825" b="1">
                 <a:solidFill>
                   <a:srgbClr val="98A2B3"/>
@@ -13289,6 +13509,7 @@
           <a:lstStyle xmlns:a="http://schemas.openxmlformats.org/drawingml/2006/main"/>
           <a:p xmlns:a="http://schemas.openxmlformats.org/drawingml/2006/main">
             <a:pPr algn="l">
+              <a:buNone/>
               <a:defRPr sz="900" b="1">
                 <a:solidFill>
                   <a:srgbClr val="1666D3"/>
@@ -13347,6 +13568,7 @@
           <a:lstStyle xmlns:a="http://schemas.openxmlformats.org/drawingml/2006/main"/>
           <a:p xmlns:a="http://schemas.openxmlformats.org/drawingml/2006/main">
             <a:pPr algn="l">
+              <a:buNone/>
               <a:defRPr sz="2550" b="1">
                 <a:solidFill>
                   <a:srgbClr val="101828"/>
@@ -13372,7 +13594,7 @@
       </p:sp>
       <p:cxnSp>
         <p:nvCxnSpPr>
-          <p:cNvPr id="41" name="header-line-4"/>
+          <p:cNvPr id="95" name="header-line-4"/>
           <p:cNvCxnSpPr/>
           <p:nvPr/>
         </p:nvCxnSpPr>
@@ -13427,6 +13649,7 @@
           <a:lstStyle xmlns:a="http://schemas.openxmlformats.org/drawingml/2006/main"/>
           <a:p xmlns:a="http://schemas.openxmlformats.org/drawingml/2006/main">
             <a:pPr algn="ctr">
+              <a:buNone/>
               <a:defRPr sz="900" b="1">
                 <a:solidFill>
                   <a:srgbClr val="1666D3"/>
@@ -13491,6 +13714,7 @@
           <a:lstStyle xmlns:a="http://schemas.openxmlformats.org/drawingml/2006/main"/>
           <a:p xmlns:a="http://schemas.openxmlformats.org/drawingml/2006/main">
             <a:pPr algn="ctr">
+              <a:buNone/>
               <a:defRPr sz="1275" b="1">
                 <a:solidFill>
                   <a:srgbClr val="101828"/>
@@ -13514,6 +13738,7 @@
           </a:p>
           <a:p xmlns:a="http://schemas.openxmlformats.org/drawingml/2006/main">
             <a:pPr algn="ctr">
+              <a:buNone/>
               <a:defRPr sz="1275" b="1">
                 <a:solidFill>
                   <a:srgbClr val="101828"/>
@@ -13572,6 +13797,7 @@
           <a:lstStyle xmlns:a="http://schemas.openxmlformats.org/drawingml/2006/main"/>
           <a:p xmlns:a="http://schemas.openxmlformats.org/drawingml/2006/main">
             <a:pPr algn="ctr">
+              <a:buNone/>
               <a:defRPr sz="1500" b="0">
                 <a:solidFill>
                   <a:srgbClr val="98A2B3"/>
@@ -13630,6 +13856,7 @@
           <a:lstStyle xmlns:a="http://schemas.openxmlformats.org/drawingml/2006/main"/>
           <a:p xmlns:a="http://schemas.openxmlformats.org/drawingml/2006/main">
             <a:pPr algn="ctr">
+              <a:buNone/>
               <a:defRPr sz="900" b="1">
                 <a:solidFill>
                   <a:srgbClr val="1666D3"/>
@@ -13694,6 +13921,7 @@
           <a:lstStyle xmlns:a="http://schemas.openxmlformats.org/drawingml/2006/main"/>
           <a:p xmlns:a="http://schemas.openxmlformats.org/drawingml/2006/main">
             <a:pPr algn="ctr">
+              <a:buNone/>
               <a:defRPr sz="1275" b="1">
                 <a:solidFill>
                   <a:srgbClr val="101828"/>
@@ -13717,6 +13945,7 @@
           </a:p>
           <a:p xmlns:a="http://schemas.openxmlformats.org/drawingml/2006/main">
             <a:pPr algn="ctr">
+              <a:buNone/>
               <a:defRPr sz="1275" b="1">
                 <a:solidFill>
                   <a:srgbClr val="101828"/>
@@ -13775,6 +14004,7 @@
           <a:lstStyle xmlns:a="http://schemas.openxmlformats.org/drawingml/2006/main"/>
           <a:p xmlns:a="http://schemas.openxmlformats.org/drawingml/2006/main">
             <a:pPr algn="ctr">
+              <a:buNone/>
               <a:defRPr sz="1500" b="0">
                 <a:solidFill>
                   <a:srgbClr val="98A2B3"/>
@@ -13833,6 +14063,7 @@
           <a:lstStyle xmlns:a="http://schemas.openxmlformats.org/drawingml/2006/main"/>
           <a:p xmlns:a="http://schemas.openxmlformats.org/drawingml/2006/main">
             <a:pPr algn="ctr">
+              <a:buNone/>
               <a:defRPr sz="900" b="1">
                 <a:solidFill>
                   <a:srgbClr val="1666D3"/>
@@ -13897,6 +14128,7 @@
           <a:lstStyle xmlns:a="http://schemas.openxmlformats.org/drawingml/2006/main"/>
           <a:p xmlns:a="http://schemas.openxmlformats.org/drawingml/2006/main">
             <a:pPr algn="ctr">
+              <a:buNone/>
               <a:defRPr sz="1275" b="1">
                 <a:solidFill>
                   <a:srgbClr val="101828"/>
@@ -13920,6 +14152,7 @@
           </a:p>
           <a:p xmlns:a="http://schemas.openxmlformats.org/drawingml/2006/main">
             <a:pPr algn="ctr">
+              <a:buNone/>
               <a:defRPr sz="1275" b="1">
                 <a:solidFill>
                   <a:srgbClr val="101828"/>
@@ -13978,6 +14211,7 @@
           <a:lstStyle xmlns:a="http://schemas.openxmlformats.org/drawingml/2006/main"/>
           <a:p xmlns:a="http://schemas.openxmlformats.org/drawingml/2006/main">
             <a:pPr algn="ctr">
+              <a:buNone/>
               <a:defRPr sz="1500" b="0">
                 <a:solidFill>
                   <a:srgbClr val="98A2B3"/>
@@ -14036,6 +14270,7 @@
           <a:lstStyle xmlns:a="http://schemas.openxmlformats.org/drawingml/2006/main"/>
           <a:p xmlns:a="http://schemas.openxmlformats.org/drawingml/2006/main">
             <a:pPr algn="ctr">
+              <a:buNone/>
               <a:defRPr sz="900" b="1">
                 <a:solidFill>
                   <a:srgbClr val="1666D3"/>
@@ -14100,6 +14335,7 @@
           <a:lstStyle xmlns:a="http://schemas.openxmlformats.org/drawingml/2006/main"/>
           <a:p xmlns:a="http://schemas.openxmlformats.org/drawingml/2006/main">
             <a:pPr algn="ctr">
+              <a:buNone/>
               <a:defRPr sz="1275" b="1">
                 <a:solidFill>
                   <a:srgbClr val="101828"/>
@@ -14123,6 +14359,7 @@
           </a:p>
           <a:p xmlns:a="http://schemas.openxmlformats.org/drawingml/2006/main">
             <a:pPr algn="ctr">
+              <a:buNone/>
               <a:defRPr sz="1275" b="1">
                 <a:solidFill>
                   <a:srgbClr val="101828"/>
@@ -14181,6 +14418,7 @@
           <a:lstStyle xmlns:a="http://schemas.openxmlformats.org/drawingml/2006/main"/>
           <a:p xmlns:a="http://schemas.openxmlformats.org/drawingml/2006/main">
             <a:pPr algn="ctr">
+              <a:buNone/>
               <a:defRPr sz="1500" b="0">
                 <a:solidFill>
                   <a:srgbClr val="98A2B3"/>
@@ -14239,6 +14477,7 @@
           <a:lstStyle xmlns:a="http://schemas.openxmlformats.org/drawingml/2006/main"/>
           <a:p xmlns:a="http://schemas.openxmlformats.org/drawingml/2006/main">
             <a:pPr algn="ctr">
+              <a:buNone/>
               <a:defRPr sz="900" b="1">
                 <a:solidFill>
                   <a:srgbClr val="1666D3"/>
@@ -14303,6 +14542,7 @@
           <a:lstStyle xmlns:a="http://schemas.openxmlformats.org/drawingml/2006/main"/>
           <a:p xmlns:a="http://schemas.openxmlformats.org/drawingml/2006/main">
             <a:pPr algn="ctr">
+              <a:buNone/>
               <a:defRPr sz="1275" b="1">
                 <a:solidFill>
                   <a:srgbClr val="101828"/>
@@ -14326,6 +14566,7 @@
           </a:p>
           <a:p xmlns:a="http://schemas.openxmlformats.org/drawingml/2006/main">
             <a:pPr algn="ctr">
+              <a:buNone/>
               <a:defRPr sz="1275" b="1">
                 <a:solidFill>
                   <a:srgbClr val="101828"/>
@@ -14384,6 +14625,7 @@
           <a:lstStyle xmlns:a="http://schemas.openxmlformats.org/drawingml/2006/main"/>
           <a:p xmlns:a="http://schemas.openxmlformats.org/drawingml/2006/main">
             <a:pPr algn="ctr">
+              <a:buNone/>
               <a:defRPr sz="1500" b="0">
                 <a:solidFill>
                   <a:srgbClr val="98A2B3"/>
@@ -14442,6 +14684,7 @@
           <a:lstStyle xmlns:a="http://schemas.openxmlformats.org/drawingml/2006/main"/>
           <a:p xmlns:a="http://schemas.openxmlformats.org/drawingml/2006/main">
             <a:pPr algn="ctr">
+              <a:buNone/>
               <a:defRPr sz="900" b="1">
                 <a:solidFill>
                   <a:srgbClr val="1666D3"/>
@@ -14506,6 +14749,7 @@
           <a:lstStyle xmlns:a="http://schemas.openxmlformats.org/drawingml/2006/main"/>
           <a:p xmlns:a="http://schemas.openxmlformats.org/drawingml/2006/main">
             <a:pPr algn="ctr">
+              <a:buNone/>
               <a:defRPr sz="1275" b="1">
                 <a:solidFill>
                   <a:srgbClr val="101828"/>
@@ -14529,6 +14773,7 @@
           </a:p>
           <a:p xmlns:a="http://schemas.openxmlformats.org/drawingml/2006/main">
             <a:pPr algn="ctr">
+              <a:buNone/>
               <a:defRPr sz="1275" b="1">
                 <a:solidFill>
                   <a:srgbClr val="101828"/>
@@ -14587,6 +14832,7 @@
           <a:lstStyle xmlns:a="http://schemas.openxmlformats.org/drawingml/2006/main"/>
           <a:p xmlns:a="http://schemas.openxmlformats.org/drawingml/2006/main">
             <a:pPr algn="ctr">
+              <a:buNone/>
               <a:defRPr sz="1500" b="0">
                 <a:solidFill>
                   <a:srgbClr val="98A2B3"/>
@@ -14645,6 +14891,7 @@
           <a:lstStyle xmlns:a="http://schemas.openxmlformats.org/drawingml/2006/main"/>
           <a:p xmlns:a="http://schemas.openxmlformats.org/drawingml/2006/main">
             <a:pPr algn="ctr">
+              <a:buNone/>
               <a:defRPr sz="900" b="1">
                 <a:solidFill>
                   <a:srgbClr val="C83838"/>
@@ -14709,6 +14956,7 @@
           <a:lstStyle xmlns:a="http://schemas.openxmlformats.org/drawingml/2006/main"/>
           <a:p xmlns:a="http://schemas.openxmlformats.org/drawingml/2006/main">
             <a:pPr algn="ctr">
+              <a:buNone/>
               <a:defRPr sz="1275" b="1">
                 <a:solidFill>
                   <a:srgbClr val="101828"/>
@@ -14732,6 +14980,7 @@
           </a:p>
           <a:p xmlns:a="http://schemas.openxmlformats.org/drawingml/2006/main">
             <a:pPr algn="ctr">
+              <a:buNone/>
               <a:defRPr sz="1275" b="1">
                 <a:solidFill>
                   <a:srgbClr val="101828"/>
@@ -14790,6 +15039,7 @@
           <a:lstStyle xmlns:a="http://schemas.openxmlformats.org/drawingml/2006/main"/>
           <a:p xmlns:a="http://schemas.openxmlformats.org/drawingml/2006/main">
             <a:pPr algn="ctr">
+              <a:buNone/>
               <a:defRPr sz="1500" b="0">
                 <a:solidFill>
                   <a:srgbClr val="98A2B3"/>
@@ -14848,6 +15098,7 @@
           <a:lstStyle xmlns:a="http://schemas.openxmlformats.org/drawingml/2006/main"/>
           <a:p xmlns:a="http://schemas.openxmlformats.org/drawingml/2006/main">
             <a:pPr algn="ctr">
+              <a:buNone/>
               <a:defRPr sz="900" b="1">
                 <a:solidFill>
                   <a:srgbClr val="16865B"/>
@@ -14912,6 +15163,7 @@
           <a:lstStyle xmlns:a="http://schemas.openxmlformats.org/drawingml/2006/main"/>
           <a:p xmlns:a="http://schemas.openxmlformats.org/drawingml/2006/main">
             <a:pPr algn="ctr">
+              <a:buNone/>
               <a:defRPr sz="1275" b="1">
                 <a:solidFill>
                   <a:srgbClr val="101828"/>
@@ -14935,6 +15187,7 @@
           </a:p>
           <a:p xmlns:a="http://schemas.openxmlformats.org/drawingml/2006/main">
             <a:pPr algn="ctr">
+              <a:buNone/>
               <a:defRPr sz="1275" b="1">
                 <a:solidFill>
                   <a:srgbClr val="101828"/>
@@ -14960,7 +15213,7 @@
       </p:sp>
       <p:cxnSp>
         <p:nvCxnSpPr>
-          <p:cNvPr id="65" name="chain-rule"/>
+          <p:cNvPr id="119" name="chain-rule"/>
           <p:cNvCxnSpPr/>
           <p:nvPr/>
         </p:nvCxnSpPr>
@@ -15015,6 +15268,7 @@
           <a:lstStyle xmlns:a="http://schemas.openxmlformats.org/drawingml/2006/main"/>
           <a:p xmlns:a="http://schemas.openxmlformats.org/drawingml/2006/main">
             <a:pPr algn="ctr">
+              <a:buNone/>
               <a:defRPr sz="1875" b="1">
                 <a:solidFill>
                   <a:srgbClr val="0B3B75"/>
@@ -15073,6 +15327,7 @@
           <a:lstStyle xmlns:a="http://schemas.openxmlformats.org/drawingml/2006/main"/>
           <a:p xmlns:a="http://schemas.openxmlformats.org/drawingml/2006/main">
             <a:pPr algn="ctr">
+              <a:buNone/>
               <a:defRPr sz="1125" b="0">
                 <a:solidFill>
                   <a:srgbClr val="667085"/>
@@ -15131,6 +15386,7 @@
           <a:lstStyle xmlns:a="http://schemas.openxmlformats.org/drawingml/2006/main"/>
           <a:p xmlns:a="http://schemas.openxmlformats.org/drawingml/2006/main">
             <a:pPr algn="ctr">
+              <a:buNone/>
               <a:defRPr sz="1875" b="1">
                 <a:solidFill>
                   <a:srgbClr val="0B3B75"/>
@@ -15189,6 +15445,7 @@
           <a:lstStyle xmlns:a="http://schemas.openxmlformats.org/drawingml/2006/main"/>
           <a:p xmlns:a="http://schemas.openxmlformats.org/drawingml/2006/main">
             <a:pPr algn="ctr">
+              <a:buNone/>
               <a:defRPr sz="1125" b="0">
                 <a:solidFill>
                   <a:srgbClr val="667085"/>
@@ -15247,6 +15504,7 @@
           <a:lstStyle xmlns:a="http://schemas.openxmlformats.org/drawingml/2006/main"/>
           <a:p xmlns:a="http://schemas.openxmlformats.org/drawingml/2006/main">
             <a:pPr algn="ctr">
+              <a:buNone/>
               <a:defRPr sz="1875" b="1">
                 <a:solidFill>
                   <a:srgbClr val="0B3B75"/>
@@ -15305,6 +15563,7 @@
           <a:lstStyle xmlns:a="http://schemas.openxmlformats.org/drawingml/2006/main"/>
           <a:p xmlns:a="http://schemas.openxmlformats.org/drawingml/2006/main">
             <a:pPr algn="ctr">
+              <a:buNone/>
               <a:defRPr sz="1125" b="0">
                 <a:solidFill>
                   <a:srgbClr val="667085"/>
@@ -15363,6 +15622,7 @@
           <a:lstStyle xmlns:a="http://schemas.openxmlformats.org/drawingml/2006/main"/>
           <a:p xmlns:a="http://schemas.openxmlformats.org/drawingml/2006/main">
             <a:pPr algn="ctr">
+              <a:buNone/>
               <a:defRPr sz="1875" b="1">
                 <a:solidFill>
                   <a:srgbClr val="0B3B75"/>
@@ -15421,6 +15681,7 @@
           <a:lstStyle xmlns:a="http://schemas.openxmlformats.org/drawingml/2006/main"/>
           <a:p xmlns:a="http://schemas.openxmlformats.org/drawingml/2006/main">
             <a:pPr algn="ctr">
+              <a:buNone/>
               <a:defRPr sz="1125" b="0">
                 <a:solidFill>
                   <a:srgbClr val="667085"/>
@@ -15485,6 +15746,7 @@
           <a:lstStyle xmlns:a="http://schemas.openxmlformats.org/drawingml/2006/main"/>
           <a:p xmlns:a="http://schemas.openxmlformats.org/drawingml/2006/main">
             <a:pPr algn="ctr">
+              <a:buNone/>
               <a:defRPr sz="1200" b="1">
                 <a:solidFill>
                   <a:srgbClr val="FFFFFF"/>
@@ -15543,6 +15805,7 @@
           <a:lstStyle xmlns:a="http://schemas.openxmlformats.org/drawingml/2006/main"/>
           <a:p xmlns:a="http://schemas.openxmlformats.org/drawingml/2006/main">
             <a:pPr algn="l">
+              <a:buNone/>
               <a:defRPr sz="750" b="0">
                 <a:solidFill>
                   <a:srgbClr val="98A2B3"/>
@@ -15601,6 +15864,7 @@
           <a:lstStyle xmlns:a="http://schemas.openxmlformats.org/drawingml/2006/main"/>
           <a:p xmlns:a="http://schemas.openxmlformats.org/drawingml/2006/main">
             <a:pPr algn="r">
+              <a:buNone/>
               <a:defRPr sz="825" b="1">
                 <a:solidFill>
                   <a:srgbClr val="98A2B3"/>
@@ -15688,6 +15952,7 @@
           <a:lstStyle xmlns:a="http://schemas.openxmlformats.org/drawingml/2006/main"/>
           <a:p xmlns:a="http://schemas.openxmlformats.org/drawingml/2006/main">
             <a:pPr algn="l">
+              <a:buNone/>
               <a:defRPr sz="900" b="1">
                 <a:solidFill>
                   <a:srgbClr val="1666D3"/>
@@ -15746,6 +16011,7 @@
           <a:lstStyle xmlns:a="http://schemas.openxmlformats.org/drawingml/2006/main"/>
           <a:p xmlns:a="http://schemas.openxmlformats.org/drawingml/2006/main">
             <a:pPr algn="l">
+              <a:buNone/>
               <a:defRPr sz="2550" b="1">
                 <a:solidFill>
                   <a:srgbClr val="101828"/>
@@ -15771,7 +16037,7 @@
       </p:sp>
       <p:cxnSp>
         <p:nvCxnSpPr>
-          <p:cNvPr id="32" name="header-line-5"/>
+          <p:cNvPr id="38" name="header-line-5"/>
           <p:cNvCxnSpPr/>
           <p:nvPr/>
         </p:nvCxnSpPr>
@@ -15832,6 +16098,7 @@
           <a:lstStyle xmlns:a="http://schemas.openxmlformats.org/drawingml/2006/main"/>
           <a:p xmlns:a="http://schemas.openxmlformats.org/drawingml/2006/main">
             <a:pPr algn="ctr">
+              <a:buNone/>
               <a:defRPr sz="1350" b="1">
                 <a:solidFill>
                   <a:srgbClr val="1666D3"/>
@@ -15855,6 +16122,7 @@
           </a:p>
           <a:p xmlns:a="http://schemas.openxmlformats.org/drawingml/2006/main">
             <a:pPr algn="ctr">
+              <a:buNone/>
               <a:defRPr sz="1350" b="1">
                 <a:solidFill>
                   <a:srgbClr val="1666D3"/>
@@ -15913,6 +16181,7 @@
           <a:lstStyle xmlns:a="http://schemas.openxmlformats.org/drawingml/2006/main"/>
           <a:p xmlns:a="http://schemas.openxmlformats.org/drawingml/2006/main">
             <a:pPr algn="ctr">
+              <a:buNone/>
               <a:defRPr sz="1500" b="0">
                 <a:solidFill>
                   <a:srgbClr val="98A2B3"/>
@@ -15977,6 +16246,7 @@
           <a:lstStyle xmlns:a="http://schemas.openxmlformats.org/drawingml/2006/main"/>
           <a:p xmlns:a="http://schemas.openxmlformats.org/drawingml/2006/main">
             <a:pPr algn="ctr">
+              <a:buNone/>
               <a:defRPr sz="1350" b="1">
                 <a:solidFill>
                   <a:srgbClr val="1666D3"/>
@@ -16000,6 +16270,7 @@
           </a:p>
           <a:p xmlns:a="http://schemas.openxmlformats.org/drawingml/2006/main">
             <a:pPr algn="ctr">
+              <a:buNone/>
               <a:defRPr sz="1350" b="1">
                 <a:solidFill>
                   <a:srgbClr val="1666D3"/>
@@ -16058,6 +16329,7 @@
           <a:lstStyle xmlns:a="http://schemas.openxmlformats.org/drawingml/2006/main"/>
           <a:p xmlns:a="http://schemas.openxmlformats.org/drawingml/2006/main">
             <a:pPr algn="ctr">
+              <a:buNone/>
               <a:defRPr sz="1500" b="0">
                 <a:solidFill>
                   <a:srgbClr val="98A2B3"/>
@@ -16122,6 +16394,7 @@
           <a:lstStyle xmlns:a="http://schemas.openxmlformats.org/drawingml/2006/main"/>
           <a:p xmlns:a="http://schemas.openxmlformats.org/drawingml/2006/main">
             <a:pPr algn="ctr">
+              <a:buNone/>
               <a:defRPr sz="1350" b="1">
                 <a:solidFill>
                   <a:srgbClr val="1666D3"/>
@@ -16145,6 +16418,7 @@
           </a:p>
           <a:p xmlns:a="http://schemas.openxmlformats.org/drawingml/2006/main">
             <a:pPr algn="ctr">
+              <a:buNone/>
               <a:defRPr sz="1350" b="1">
                 <a:solidFill>
                   <a:srgbClr val="1666D3"/>
@@ -16203,6 +16477,7 @@
           <a:lstStyle xmlns:a="http://schemas.openxmlformats.org/drawingml/2006/main"/>
           <a:p xmlns:a="http://schemas.openxmlformats.org/drawingml/2006/main">
             <a:pPr algn="ctr">
+              <a:buNone/>
               <a:defRPr sz="1500" b="0">
                 <a:solidFill>
                   <a:srgbClr val="98A2B3"/>
@@ -16267,6 +16542,7 @@
           <a:lstStyle xmlns:a="http://schemas.openxmlformats.org/drawingml/2006/main"/>
           <a:p xmlns:a="http://schemas.openxmlformats.org/drawingml/2006/main">
             <a:pPr algn="ctr">
+              <a:buNone/>
               <a:defRPr sz="1350" b="1">
                 <a:solidFill>
                   <a:srgbClr val="1666D3"/>
@@ -16290,6 +16566,7 @@
           </a:p>
           <a:p xmlns:a="http://schemas.openxmlformats.org/drawingml/2006/main">
             <a:pPr algn="ctr">
+              <a:buNone/>
               <a:defRPr sz="1350" b="1">
                 <a:solidFill>
                   <a:srgbClr val="1666D3"/>
@@ -16348,6 +16625,7 @@
           <a:lstStyle xmlns:a="http://schemas.openxmlformats.org/drawingml/2006/main"/>
           <a:p xmlns:a="http://schemas.openxmlformats.org/drawingml/2006/main">
             <a:pPr algn="ctr">
+              <a:buNone/>
               <a:defRPr sz="1500" b="0">
                 <a:solidFill>
                   <a:srgbClr val="98A2B3"/>
@@ -16412,6 +16690,7 @@
           <a:lstStyle xmlns:a="http://schemas.openxmlformats.org/drawingml/2006/main"/>
           <a:p xmlns:a="http://schemas.openxmlformats.org/drawingml/2006/main">
             <a:pPr algn="ctr">
+              <a:buNone/>
               <a:defRPr sz="1350" b="1">
                 <a:solidFill>
                   <a:srgbClr val="1666D3"/>
@@ -16435,6 +16714,7 @@
           </a:p>
           <a:p xmlns:a="http://schemas.openxmlformats.org/drawingml/2006/main">
             <a:pPr algn="ctr">
+              <a:buNone/>
               <a:defRPr sz="1350" b="1">
                 <a:solidFill>
                   <a:srgbClr val="1666D3"/>
@@ -16493,6 +16773,7 @@
           <a:lstStyle xmlns:a="http://schemas.openxmlformats.org/drawingml/2006/main"/>
           <a:p xmlns:a="http://schemas.openxmlformats.org/drawingml/2006/main">
             <a:pPr algn="ctr">
+              <a:buNone/>
               <a:defRPr sz="1500" b="0">
                 <a:solidFill>
                   <a:srgbClr val="98A2B3"/>
@@ -16557,6 +16838,7 @@
           <a:lstStyle xmlns:a="http://schemas.openxmlformats.org/drawingml/2006/main"/>
           <a:p xmlns:a="http://schemas.openxmlformats.org/drawingml/2006/main">
             <a:pPr algn="ctr">
+              <a:buNone/>
               <a:defRPr sz="1350" b="1">
                 <a:solidFill>
                   <a:srgbClr val="1666D3"/>
@@ -16580,6 +16862,7 @@
           </a:p>
           <a:p xmlns:a="http://schemas.openxmlformats.org/drawingml/2006/main">
             <a:pPr algn="ctr">
+              <a:buNone/>
               <a:defRPr sz="1350" b="1">
                 <a:solidFill>
                   <a:srgbClr val="1666D3"/>
@@ -16638,6 +16921,7 @@
           <a:lstStyle xmlns:a="http://schemas.openxmlformats.org/drawingml/2006/main"/>
           <a:p xmlns:a="http://schemas.openxmlformats.org/drawingml/2006/main">
             <a:pPr algn="ctr">
+              <a:buNone/>
               <a:defRPr sz="1500" b="0">
                 <a:solidFill>
                   <a:srgbClr val="98A2B3"/>
@@ -16702,6 +16986,7 @@
           <a:lstStyle xmlns:a="http://schemas.openxmlformats.org/drawingml/2006/main"/>
           <a:p xmlns:a="http://schemas.openxmlformats.org/drawingml/2006/main">
             <a:pPr algn="ctr">
+              <a:buNone/>
               <a:defRPr sz="1350" b="1">
                 <a:solidFill>
                   <a:srgbClr val="C83838"/>
@@ -16725,6 +17010,7 @@
           </a:p>
           <a:p xmlns:a="http://schemas.openxmlformats.org/drawingml/2006/main">
             <a:pPr algn="ctr">
+              <a:buNone/>
               <a:defRPr sz="1350" b="1">
                 <a:solidFill>
                   <a:srgbClr val="C83838"/>
@@ -16783,6 +17069,7 @@
           <a:lstStyle xmlns:a="http://schemas.openxmlformats.org/drawingml/2006/main"/>
           <a:p xmlns:a="http://schemas.openxmlformats.org/drawingml/2006/main">
             <a:pPr algn="ctr">
+              <a:buNone/>
               <a:defRPr sz="1500" b="0">
                 <a:solidFill>
                   <a:srgbClr val="98A2B3"/>
@@ -16847,6 +17134,7 @@
           <a:lstStyle xmlns:a="http://schemas.openxmlformats.org/drawingml/2006/main"/>
           <a:p xmlns:a="http://schemas.openxmlformats.org/drawingml/2006/main">
             <a:pPr algn="ctr">
+              <a:buNone/>
               <a:defRPr sz="1350" b="1">
                 <a:solidFill>
                   <a:srgbClr val="16865B"/>
@@ -16870,6 +17158,7 @@
           </a:p>
           <a:p xmlns:a="http://schemas.openxmlformats.org/drawingml/2006/main">
             <a:pPr algn="ctr">
+              <a:buNone/>
               <a:defRPr sz="1350" b="1">
                 <a:solidFill>
                   <a:srgbClr val="16865B"/>
@@ -16928,6 +17217,7 @@
           <a:lstStyle xmlns:a="http://schemas.openxmlformats.org/drawingml/2006/main"/>
           <a:p xmlns:a="http://schemas.openxmlformats.org/drawingml/2006/main">
             <a:pPr algn="l">
+              <a:buNone/>
               <a:defRPr sz="975" b="1">
                 <a:solidFill>
                   <a:srgbClr val="98A2B3"/>
@@ -16992,6 +17282,7 @@
           <a:lstStyle xmlns:a="http://schemas.openxmlformats.org/drawingml/2006/main"/>
           <a:p xmlns:a="http://schemas.openxmlformats.org/drawingml/2006/main">
             <a:pPr algn="ctr">
+              <a:buNone/>
               <a:defRPr sz="1200" b="1">
                 <a:solidFill>
                   <a:srgbClr val="E7EEF7"/>
@@ -17050,6 +17341,7 @@
           <a:lstStyle xmlns:a="http://schemas.openxmlformats.org/drawingml/2006/main"/>
           <a:p xmlns:a="http://schemas.openxmlformats.org/drawingml/2006/main">
             <a:pPr algn="l">
+              <a:buNone/>
               <a:defRPr sz="975" b="1">
                 <a:solidFill>
                   <a:srgbClr val="98A2B3"/>
@@ -17114,6 +17406,7 @@
           <a:lstStyle xmlns:a="http://schemas.openxmlformats.org/drawingml/2006/main"/>
           <a:p xmlns:a="http://schemas.openxmlformats.org/drawingml/2006/main">
             <a:pPr algn="ctr">
+              <a:buNone/>
               <a:defRPr sz="1125" b="1">
                 <a:solidFill>
                   <a:srgbClr val="101828"/>
@@ -17137,6 +17430,7 @@
           </a:p>
           <a:p xmlns:a="http://schemas.openxmlformats.org/drawingml/2006/main">
             <a:pPr algn="ctr">
+              <a:buNone/>
               <a:defRPr sz="1125" b="1">
                 <a:solidFill>
                   <a:srgbClr val="101828"/>
@@ -17201,6 +17495,7 @@
           <a:lstStyle xmlns:a="http://schemas.openxmlformats.org/drawingml/2006/main"/>
           <a:p xmlns:a="http://schemas.openxmlformats.org/drawingml/2006/main">
             <a:pPr algn="ctr">
+              <a:buNone/>
               <a:defRPr sz="1125" b="1">
                 <a:solidFill>
                   <a:srgbClr val="101828"/>
@@ -17224,6 +17519,7 @@
           </a:p>
           <a:p xmlns:a="http://schemas.openxmlformats.org/drawingml/2006/main">
             <a:pPr algn="ctr">
+              <a:buNone/>
               <a:defRPr sz="1125" b="1">
                 <a:solidFill>
                   <a:srgbClr val="101828"/>
@@ -17288,6 +17584,7 @@
           <a:lstStyle xmlns:a="http://schemas.openxmlformats.org/drawingml/2006/main"/>
           <a:p xmlns:a="http://schemas.openxmlformats.org/drawingml/2006/main">
             <a:pPr algn="ctr">
+              <a:buNone/>
               <a:defRPr sz="1125" b="1">
                 <a:solidFill>
                   <a:srgbClr val="C83838"/>
@@ -17311,6 +17608,7 @@
           </a:p>
           <a:p xmlns:a="http://schemas.openxmlformats.org/drawingml/2006/main">
             <a:pPr algn="ctr">
+              <a:buNone/>
               <a:defRPr sz="1125" b="1">
                 <a:solidFill>
                   <a:srgbClr val="C83838"/>
@@ -17375,6 +17673,7 @@
           <a:lstStyle xmlns:a="http://schemas.openxmlformats.org/drawingml/2006/main"/>
           <a:p xmlns:a="http://schemas.openxmlformats.org/drawingml/2006/main">
             <a:pPr algn="ctr">
+              <a:buNone/>
               <a:defRPr sz="1125" b="1">
                 <a:solidFill>
                   <a:srgbClr val="C83838"/>
@@ -17398,6 +17697,7 @@
           </a:p>
           <a:p xmlns:a="http://schemas.openxmlformats.org/drawingml/2006/main">
             <a:pPr algn="ctr">
+              <a:buNone/>
               <a:defRPr sz="1125" b="1">
                 <a:solidFill>
                   <a:srgbClr val="C83838"/>
@@ -17462,6 +17762,7 @@
           <a:lstStyle xmlns:a="http://schemas.openxmlformats.org/drawingml/2006/main"/>
           <a:p xmlns:a="http://schemas.openxmlformats.org/drawingml/2006/main">
             <a:pPr algn="ctr">
+              <a:buNone/>
               <a:defRPr sz="1125" b="1">
                 <a:solidFill>
                   <a:srgbClr val="101828"/>
@@ -17485,6 +17786,7 @@
           </a:p>
           <a:p xmlns:a="http://schemas.openxmlformats.org/drawingml/2006/main">
             <a:pPr algn="ctr">
+              <a:buNone/>
               <a:defRPr sz="1125" b="1">
                 <a:solidFill>
                   <a:srgbClr val="101828"/>
@@ -17543,6 +17845,7 @@
           <a:lstStyle xmlns:a="http://schemas.openxmlformats.org/drawingml/2006/main"/>
           <a:p xmlns:a="http://schemas.openxmlformats.org/drawingml/2006/main">
             <a:pPr algn="ctr">
+              <a:buNone/>
               <a:defRPr sz="1650" b="1">
                 <a:solidFill>
                   <a:srgbClr val="0B3B75"/>
@@ -17601,6 +17904,7 @@
           <a:lstStyle xmlns:a="http://schemas.openxmlformats.org/drawingml/2006/main"/>
           <a:p xmlns:a="http://schemas.openxmlformats.org/drawingml/2006/main">
             <a:pPr algn="l">
+              <a:buNone/>
               <a:defRPr sz="750" b="0">
                 <a:solidFill>
                   <a:srgbClr val="98A2B3"/>
@@ -17659,6 +17963,7 @@
           <a:lstStyle xmlns:a="http://schemas.openxmlformats.org/drawingml/2006/main"/>
           <a:p xmlns:a="http://schemas.openxmlformats.org/drawingml/2006/main">
             <a:pPr algn="r">
+              <a:buNone/>
               <a:defRPr sz="825" b="1">
                 <a:solidFill>
                   <a:srgbClr val="98A2B3"/>
@@ -17746,6 +18051,7 @@
           <a:lstStyle xmlns:a="http://schemas.openxmlformats.org/drawingml/2006/main"/>
           <a:p xmlns:a="http://schemas.openxmlformats.org/drawingml/2006/main">
             <a:pPr algn="l">
+              <a:buNone/>
               <a:defRPr sz="900" b="1">
                 <a:solidFill>
                   <a:srgbClr val="1666D3"/>
@@ -17804,6 +18110,7 @@
           <a:lstStyle xmlns:a="http://schemas.openxmlformats.org/drawingml/2006/main"/>
           <a:p xmlns:a="http://schemas.openxmlformats.org/drawingml/2006/main">
             <a:pPr algn="l">
+              <a:buNone/>
               <a:defRPr sz="2550" b="1">
                 <a:solidFill>
                   <a:srgbClr val="101828"/>
@@ -17829,7 +18136,7 @@
       </p:sp>
       <p:cxnSp>
         <p:nvCxnSpPr>
-          <p:cNvPr id="30" name="header-line-6"/>
+          <p:cNvPr id="36" name="header-line-6"/>
           <p:cNvCxnSpPr/>
           <p:nvPr/>
         </p:nvCxnSpPr>
@@ -17919,6 +18226,7 @@
           <a:lstStyle xmlns:a="http://schemas.openxmlformats.org/drawingml/2006/main"/>
           <a:p xmlns:a="http://schemas.openxmlformats.org/drawingml/2006/main">
             <a:pPr algn="ctr">
+              <a:buNone/>
               <a:defRPr sz="1500" b="1">
                 <a:solidFill>
                   <a:srgbClr val="101828"/>
@@ -17977,6 +18285,7 @@
           <a:lstStyle xmlns:a="http://schemas.openxmlformats.org/drawingml/2006/main"/>
           <a:p xmlns:a="http://schemas.openxmlformats.org/drawingml/2006/main">
             <a:pPr algn="ctr">
+              <a:buNone/>
               <a:defRPr sz="1500" b="1">
                 <a:solidFill>
                   <a:srgbClr val="667085"/>
@@ -18000,6 +18309,7 @@
           </a:p>
           <a:p xmlns:a="http://schemas.openxmlformats.org/drawingml/2006/main">
             <a:pPr algn="ctr">
+              <a:buNone/>
               <a:defRPr sz="1500" b="1">
                 <a:solidFill>
                   <a:srgbClr val="667085"/>
@@ -18023,6 +18333,7 @@
           </a:p>
           <a:p xmlns:a="http://schemas.openxmlformats.org/drawingml/2006/main">
             <a:pPr algn="ctr">
+              <a:buNone/>
               <a:defRPr sz="1500" b="1">
                 <a:solidFill>
                   <a:srgbClr val="667085"/>
@@ -18087,6 +18398,7 @@
           <a:lstStyle xmlns:a="http://schemas.openxmlformats.org/drawingml/2006/main"/>
           <a:p xmlns:a="http://schemas.openxmlformats.org/drawingml/2006/main">
             <a:pPr algn="ctr">
+              <a:buNone/>
               <a:defRPr sz="900" b="1">
                 <a:solidFill>
                   <a:srgbClr val="16865B"/>
@@ -18145,6 +18457,7 @@
           <a:lstStyle xmlns:a="http://schemas.openxmlformats.org/drawingml/2006/main"/>
           <a:p xmlns:a="http://schemas.openxmlformats.org/drawingml/2006/main">
             <a:pPr algn="ctr">
+              <a:buNone/>
               <a:defRPr sz="2025" b="1">
                 <a:solidFill>
                   <a:srgbClr val="98A2B3"/>
@@ -18238,6 +18551,7 @@
           <a:lstStyle xmlns:a="http://schemas.openxmlformats.org/drawingml/2006/main"/>
           <a:p xmlns:a="http://schemas.openxmlformats.org/drawingml/2006/main">
             <a:pPr algn="ctr">
+              <a:buNone/>
               <a:defRPr sz="975" b="1">
                 <a:solidFill>
                   <a:srgbClr val="BBD4F3"/>
@@ -18296,6 +18610,7 @@
           <a:lstStyle xmlns:a="http://schemas.openxmlformats.org/drawingml/2006/main"/>
           <a:p xmlns:a="http://schemas.openxmlformats.org/drawingml/2006/main">
             <a:pPr algn="ctr">
+              <a:buNone/>
               <a:defRPr sz="1875" b="1">
                 <a:solidFill>
                   <a:srgbClr val="FFFFFF"/>
@@ -18354,6 +18669,7 @@
           <a:lstStyle xmlns:a="http://schemas.openxmlformats.org/drawingml/2006/main"/>
           <a:p xmlns:a="http://schemas.openxmlformats.org/drawingml/2006/main">
             <a:pPr algn="ctr">
+              <a:buNone/>
               <a:defRPr sz="1350" b="1">
                 <a:solidFill>
                   <a:srgbClr val="E1ECFA"/>
@@ -18377,6 +18693,7 @@
           </a:p>
           <a:p xmlns:a="http://schemas.openxmlformats.org/drawingml/2006/main">
             <a:pPr algn="ctr">
+              <a:buNone/>
               <a:defRPr sz="1350" b="1">
                 <a:solidFill>
                   <a:srgbClr val="E1ECFA"/>
@@ -18400,6 +18717,7 @@
           </a:p>
           <a:p xmlns:a="http://schemas.openxmlformats.org/drawingml/2006/main">
             <a:pPr algn="ctr">
+              <a:buNone/>
               <a:defRPr sz="1350" b="1">
                 <a:solidFill>
                   <a:srgbClr val="E1ECFA"/>
@@ -18423,6 +18741,7 @@
           </a:p>
           <a:p xmlns:a="http://schemas.openxmlformats.org/drawingml/2006/main">
             <a:pPr algn="ctr">
+              <a:buNone/>
               <a:defRPr sz="1350" b="1">
                 <a:solidFill>
                   <a:srgbClr val="E1ECFA"/>
@@ -18481,6 +18800,7 @@
           <a:lstStyle xmlns:a="http://schemas.openxmlformats.org/drawingml/2006/main"/>
           <a:p xmlns:a="http://schemas.openxmlformats.org/drawingml/2006/main">
             <a:pPr algn="ctr">
+              <a:buNone/>
               <a:defRPr sz="2025" b="1">
                 <a:solidFill>
                   <a:srgbClr val="98A2B3"/>
@@ -18545,6 +18865,7 @@
           <a:lstStyle xmlns:a="http://schemas.openxmlformats.org/drawingml/2006/main"/>
           <a:p xmlns:a="http://schemas.openxmlformats.org/drawingml/2006/main">
             <a:pPr algn="ctr">
+              <a:buNone/>
               <a:defRPr sz="1350" b="1">
                 <a:solidFill>
                   <a:srgbClr val="1666D3"/>
@@ -18568,6 +18889,7 @@
           </a:p>
           <a:p xmlns:a="http://schemas.openxmlformats.org/drawingml/2006/main">
             <a:pPr algn="ctr">
+              <a:buNone/>
               <a:defRPr sz="1350" b="1">
                 <a:solidFill>
                   <a:srgbClr val="1666D3"/>
@@ -18632,6 +18954,7 @@
           <a:lstStyle xmlns:a="http://schemas.openxmlformats.org/drawingml/2006/main"/>
           <a:p xmlns:a="http://schemas.openxmlformats.org/drawingml/2006/main">
             <a:pPr algn="ctr">
+              <a:buNone/>
               <a:defRPr sz="1350" b="1">
                 <a:solidFill>
                   <a:srgbClr val="1666D3"/>
@@ -18655,6 +18978,7 @@
           </a:p>
           <a:p xmlns:a="http://schemas.openxmlformats.org/drawingml/2006/main">
             <a:pPr algn="ctr">
+              <a:buNone/>
               <a:defRPr sz="1350" b="1">
                 <a:solidFill>
                   <a:srgbClr val="1666D3"/>
@@ -18719,6 +19043,7 @@
           <a:lstStyle xmlns:a="http://schemas.openxmlformats.org/drawingml/2006/main"/>
           <a:p xmlns:a="http://schemas.openxmlformats.org/drawingml/2006/main">
             <a:pPr algn="ctr">
+              <a:buNone/>
               <a:defRPr sz="1350" b="1">
                 <a:solidFill>
                   <a:srgbClr val="7047B8"/>
@@ -18742,6 +19067,7 @@
           </a:p>
           <a:p xmlns:a="http://schemas.openxmlformats.org/drawingml/2006/main">
             <a:pPr algn="ctr">
+              <a:buNone/>
               <a:defRPr sz="1350" b="1">
                 <a:solidFill>
                   <a:srgbClr val="7047B8"/>
@@ -18806,6 +19132,7 @@
           <a:lstStyle xmlns:a="http://schemas.openxmlformats.org/drawingml/2006/main"/>
           <a:p xmlns:a="http://schemas.openxmlformats.org/drawingml/2006/main">
             <a:pPr algn="ctr">
+              <a:buNone/>
               <a:defRPr sz="1350" b="1">
                 <a:solidFill>
                   <a:srgbClr val="C77800"/>
@@ -18829,6 +19156,7 @@
           </a:p>
           <a:p xmlns:a="http://schemas.openxmlformats.org/drawingml/2006/main">
             <a:pPr algn="ctr">
+              <a:buNone/>
               <a:defRPr sz="1350" b="1">
                 <a:solidFill>
                   <a:srgbClr val="C77800"/>
@@ -18893,6 +19221,7 @@
           <a:lstStyle xmlns:a="http://schemas.openxmlformats.org/drawingml/2006/main"/>
           <a:p xmlns:a="http://schemas.openxmlformats.org/drawingml/2006/main">
             <a:pPr algn="ctr">
+              <a:buNone/>
               <a:defRPr sz="1350" b="1">
                 <a:solidFill>
                   <a:srgbClr val="C83838"/>
@@ -18916,6 +19245,7 @@
           </a:p>
           <a:p xmlns:a="http://schemas.openxmlformats.org/drawingml/2006/main">
             <a:pPr algn="ctr">
+              <a:buNone/>
               <a:defRPr sz="1350" b="1">
                 <a:solidFill>
                   <a:srgbClr val="C83838"/>
@@ -18974,6 +19304,7 @@
           <a:lstStyle xmlns:a="http://schemas.openxmlformats.org/drawingml/2006/main"/>
           <a:p xmlns:a="http://schemas.openxmlformats.org/drawingml/2006/main">
             <a:pPr algn="ctr">
+              <a:buNone/>
               <a:defRPr sz="1200" b="0">
                 <a:solidFill>
                   <a:srgbClr val="667085"/>
@@ -19067,6 +19398,7 @@
           <a:lstStyle xmlns:a="http://schemas.openxmlformats.org/drawingml/2006/main"/>
           <a:p xmlns:a="http://schemas.openxmlformats.org/drawingml/2006/main">
             <a:pPr algn="ctr">
+              <a:buNone/>
               <a:defRPr sz="1200" b="1">
                 <a:solidFill>
                   <a:srgbClr val="101828"/>
@@ -19125,6 +19457,7 @@
           <a:lstStyle xmlns:a="http://schemas.openxmlformats.org/drawingml/2006/main"/>
           <a:p xmlns:a="http://schemas.openxmlformats.org/drawingml/2006/main">
             <a:pPr algn="ctr">
+              <a:buNone/>
               <a:defRPr sz="1200" b="1">
                 <a:solidFill>
                   <a:srgbClr val="101828"/>
@@ -19183,6 +19516,7 @@
           <a:lstStyle xmlns:a="http://schemas.openxmlformats.org/drawingml/2006/main"/>
           <a:p xmlns:a="http://schemas.openxmlformats.org/drawingml/2006/main">
             <a:pPr algn="ctr">
+              <a:buNone/>
               <a:defRPr sz="1200" b="1">
                 <a:solidFill>
                   <a:srgbClr val="101828"/>
@@ -19241,6 +19575,7 @@
           <a:lstStyle xmlns:a="http://schemas.openxmlformats.org/drawingml/2006/main"/>
           <a:p xmlns:a="http://schemas.openxmlformats.org/drawingml/2006/main">
             <a:pPr algn="ctr">
+              <a:buNone/>
               <a:defRPr sz="1200" b="1">
                 <a:solidFill>
                   <a:srgbClr val="101828"/>
@@ -19299,6 +19634,7 @@
           <a:lstStyle xmlns:a="http://schemas.openxmlformats.org/drawingml/2006/main"/>
           <a:p xmlns:a="http://schemas.openxmlformats.org/drawingml/2006/main">
             <a:pPr algn="ctr">
+              <a:buNone/>
               <a:defRPr sz="1200" b="1">
                 <a:solidFill>
                   <a:srgbClr val="16865B"/>
@@ -19357,6 +19693,7 @@
           <a:lstStyle xmlns:a="http://schemas.openxmlformats.org/drawingml/2006/main"/>
           <a:p xmlns:a="http://schemas.openxmlformats.org/drawingml/2006/main">
             <a:pPr algn="l">
+              <a:buNone/>
               <a:defRPr sz="750" b="0">
                 <a:solidFill>
                   <a:srgbClr val="98A2B3"/>
@@ -19415,6 +19752,7 @@
           <a:lstStyle xmlns:a="http://schemas.openxmlformats.org/drawingml/2006/main"/>
           <a:p xmlns:a="http://schemas.openxmlformats.org/drawingml/2006/main">
             <a:pPr algn="r">
+              <a:buNone/>
               <a:defRPr sz="825" b="1">
                 <a:solidFill>
                   <a:srgbClr val="98A2B3"/>
@@ -19502,6 +19840,7 @@
           <a:lstStyle xmlns:a="http://schemas.openxmlformats.org/drawingml/2006/main"/>
           <a:p xmlns:a="http://schemas.openxmlformats.org/drawingml/2006/main">
             <a:pPr algn="l">
+              <a:buNone/>
               <a:defRPr sz="900" b="1">
                 <a:solidFill>
                   <a:srgbClr val="1666D3"/>
@@ -19560,6 +19899,7 @@
           <a:lstStyle xmlns:a="http://schemas.openxmlformats.org/drawingml/2006/main"/>
           <a:p xmlns:a="http://schemas.openxmlformats.org/drawingml/2006/main">
             <a:pPr algn="l">
+              <a:buNone/>
               <a:defRPr sz="2550" b="1">
                 <a:solidFill>
                   <a:srgbClr val="101828"/>
@@ -19585,7 +19925,7 @@
       </p:sp>
       <p:cxnSp>
         <p:nvCxnSpPr>
-          <p:cNvPr id="27" name="header-line-7"/>
+          <p:cNvPr id="33" name="header-line-7"/>
           <p:cNvCxnSpPr/>
           <p:nvPr/>
         </p:nvCxnSpPr>
@@ -19644,6 +19984,7 @@
           <a:lstStyle xmlns:a="http://schemas.openxmlformats.org/drawingml/2006/main"/>
           <a:p xmlns:a="http://schemas.openxmlformats.org/drawingml/2006/main">
             <a:pPr algn="ctr">
+              <a:buNone/>
               <a:defRPr sz="1350" b="1">
                 <a:solidFill>
                   <a:srgbClr val="FFFFFF"/>
@@ -19706,6 +20047,7 @@
           <a:lstStyle xmlns:a="http://schemas.openxmlformats.org/drawingml/2006/main"/>
           <a:p xmlns:a="http://schemas.openxmlformats.org/drawingml/2006/main">
             <a:pPr algn="l">
+              <a:buNone/>
               <a:defRPr sz="1350" b="1">
                 <a:solidFill>
                   <a:srgbClr val="FFFFFF"/>
@@ -19768,6 +20110,7 @@
           <a:lstStyle xmlns:a="http://schemas.openxmlformats.org/drawingml/2006/main"/>
           <a:p xmlns:a="http://schemas.openxmlformats.org/drawingml/2006/main">
             <a:pPr algn="l">
+              <a:buNone/>
               <a:defRPr sz="1350" b="1">
                 <a:solidFill>
                   <a:srgbClr val="FFFFFF"/>
@@ -19830,6 +20173,7 @@
           <a:lstStyle xmlns:a="http://schemas.openxmlformats.org/drawingml/2006/main"/>
           <a:p xmlns:a="http://schemas.openxmlformats.org/drawingml/2006/main">
             <a:pPr algn="ctr">
+              <a:buNone/>
               <a:defRPr sz="1350" b="1">
                 <a:solidFill>
                   <a:srgbClr val="1666D3"/>
@@ -19892,6 +20236,7 @@
           <a:lstStyle xmlns:a="http://schemas.openxmlformats.org/drawingml/2006/main"/>
           <a:p xmlns:a="http://schemas.openxmlformats.org/drawingml/2006/main">
             <a:pPr algn="l">
+              <a:buNone/>
               <a:defRPr sz="1350" b="0">
                 <a:solidFill>
                   <a:srgbClr val="101828"/>
@@ -19954,6 +20299,7 @@
           <a:lstStyle xmlns:a="http://schemas.openxmlformats.org/drawingml/2006/main"/>
           <a:p xmlns:a="http://schemas.openxmlformats.org/drawingml/2006/main">
             <a:pPr algn="l">
+              <a:buNone/>
               <a:defRPr sz="1275" b="1">
                 <a:solidFill>
                   <a:srgbClr val="C83838"/>
@@ -20016,6 +20362,7 @@
           <a:lstStyle xmlns:a="http://schemas.openxmlformats.org/drawingml/2006/main"/>
           <a:p xmlns:a="http://schemas.openxmlformats.org/drawingml/2006/main">
             <a:pPr algn="ctr">
+              <a:buNone/>
               <a:defRPr sz="1350" b="1">
                 <a:solidFill>
                   <a:srgbClr val="1666D3"/>
@@ -20078,6 +20425,7 @@
           <a:lstStyle xmlns:a="http://schemas.openxmlformats.org/drawingml/2006/main"/>
           <a:p xmlns:a="http://schemas.openxmlformats.org/drawingml/2006/main">
             <a:pPr algn="l">
+              <a:buNone/>
               <a:defRPr sz="1350" b="0">
                 <a:solidFill>
                   <a:srgbClr val="101828"/>
@@ -20140,6 +20488,7 @@
           <a:lstStyle xmlns:a="http://schemas.openxmlformats.org/drawingml/2006/main"/>
           <a:p xmlns:a="http://schemas.openxmlformats.org/drawingml/2006/main">
             <a:pPr algn="l">
+              <a:buNone/>
               <a:defRPr sz="1275" b="1">
                 <a:solidFill>
                   <a:srgbClr val="C83838"/>
@@ -20202,6 +20551,7 @@
           <a:lstStyle xmlns:a="http://schemas.openxmlformats.org/drawingml/2006/main"/>
           <a:p xmlns:a="http://schemas.openxmlformats.org/drawingml/2006/main">
             <a:pPr algn="ctr">
+              <a:buNone/>
               <a:defRPr sz="1350" b="1">
                 <a:solidFill>
                   <a:srgbClr val="1666D3"/>
@@ -20264,6 +20614,7 @@
           <a:lstStyle xmlns:a="http://schemas.openxmlformats.org/drawingml/2006/main"/>
           <a:p xmlns:a="http://schemas.openxmlformats.org/drawingml/2006/main">
             <a:pPr algn="l">
+              <a:buNone/>
               <a:defRPr sz="1350" b="0">
                 <a:solidFill>
                   <a:srgbClr val="101828"/>
@@ -20326,6 +20677,7 @@
           <a:lstStyle xmlns:a="http://schemas.openxmlformats.org/drawingml/2006/main"/>
           <a:p xmlns:a="http://schemas.openxmlformats.org/drawingml/2006/main">
             <a:pPr algn="l">
+              <a:buNone/>
               <a:defRPr sz="1275" b="1">
                 <a:solidFill>
                   <a:srgbClr val="C83838"/>
@@ -20388,6 +20740,7 @@
           <a:lstStyle xmlns:a="http://schemas.openxmlformats.org/drawingml/2006/main"/>
           <a:p xmlns:a="http://schemas.openxmlformats.org/drawingml/2006/main">
             <a:pPr algn="ctr">
+              <a:buNone/>
               <a:defRPr sz="1350" b="1">
                 <a:solidFill>
                   <a:srgbClr val="1666D3"/>
@@ -20450,6 +20803,7 @@
           <a:lstStyle xmlns:a="http://schemas.openxmlformats.org/drawingml/2006/main"/>
           <a:p xmlns:a="http://schemas.openxmlformats.org/drawingml/2006/main">
             <a:pPr algn="l">
+              <a:buNone/>
               <a:defRPr sz="1350" b="0">
                 <a:solidFill>
                   <a:srgbClr val="101828"/>
@@ -20512,6 +20866,7 @@
           <a:lstStyle xmlns:a="http://schemas.openxmlformats.org/drawingml/2006/main"/>
           <a:p xmlns:a="http://schemas.openxmlformats.org/drawingml/2006/main">
             <a:pPr algn="l">
+              <a:buNone/>
               <a:defRPr sz="1275" b="1">
                 <a:solidFill>
                   <a:srgbClr val="C83838"/>
@@ -20574,6 +20929,7 @@
           <a:lstStyle xmlns:a="http://schemas.openxmlformats.org/drawingml/2006/main"/>
           <a:p xmlns:a="http://schemas.openxmlformats.org/drawingml/2006/main">
             <a:pPr algn="ctr">
+              <a:buNone/>
               <a:defRPr sz="1350" b="1">
                 <a:solidFill>
                   <a:srgbClr val="1666D3"/>
@@ -20636,6 +20992,7 @@
           <a:lstStyle xmlns:a="http://schemas.openxmlformats.org/drawingml/2006/main"/>
           <a:p xmlns:a="http://schemas.openxmlformats.org/drawingml/2006/main">
             <a:pPr algn="l">
+              <a:buNone/>
               <a:defRPr sz="1350" b="0">
                 <a:solidFill>
                   <a:srgbClr val="101828"/>
@@ -20698,6 +21055,7 @@
           <a:lstStyle xmlns:a="http://schemas.openxmlformats.org/drawingml/2006/main"/>
           <a:p xmlns:a="http://schemas.openxmlformats.org/drawingml/2006/main">
             <a:pPr algn="l">
+              <a:buNone/>
               <a:defRPr sz="1275" b="1">
                 <a:solidFill>
                   <a:srgbClr val="C83838"/>
@@ -20762,6 +21120,7 @@
           <a:lstStyle xmlns:a="http://schemas.openxmlformats.org/drawingml/2006/main"/>
           <a:p xmlns:a="http://schemas.openxmlformats.org/drawingml/2006/main">
             <a:pPr algn="ctr">
+              <a:buNone/>
               <a:defRPr sz="1125" b="1">
                 <a:solidFill>
                   <a:srgbClr val="C83838"/>
@@ -20820,6 +21179,7 @@
           <a:lstStyle xmlns:a="http://schemas.openxmlformats.org/drawingml/2006/main"/>
           <a:p xmlns:a="http://schemas.openxmlformats.org/drawingml/2006/main">
             <a:pPr algn="l">
+              <a:buNone/>
               <a:defRPr sz="750" b="0">
                 <a:solidFill>
                   <a:srgbClr val="98A2B3"/>
@@ -20878,6 +21238,7 @@
           <a:lstStyle xmlns:a="http://schemas.openxmlformats.org/drawingml/2006/main"/>
           <a:p xmlns:a="http://schemas.openxmlformats.org/drawingml/2006/main">
             <a:pPr algn="r">
+              <a:buNone/>
               <a:defRPr sz="825" b="1">
                 <a:solidFill>
                   <a:srgbClr val="98A2B3"/>
@@ -21000,6 +21361,7 @@
           <a:lstStyle xmlns:a="http://schemas.openxmlformats.org/drawingml/2006/main"/>
           <a:p xmlns:a="http://schemas.openxmlformats.org/drawingml/2006/main">
             <a:pPr algn="l">
+              <a:buNone/>
               <a:defRPr sz="1575" b="1">
                 <a:solidFill>
                   <a:srgbClr val="101828"/>
@@ -21058,6 +21420,7 @@
           <a:lstStyle xmlns:a="http://schemas.openxmlformats.org/drawingml/2006/main"/>
           <a:p xmlns:a="http://schemas.openxmlformats.org/drawingml/2006/main">
             <a:pPr algn="l">
+              <a:buNone/>
               <a:defRPr sz="1350" b="1">
                 <a:solidFill>
                   <a:srgbClr val="101828"/>
@@ -21081,6 +21444,7 @@
           </a:p>
           <a:p xmlns:a="http://schemas.openxmlformats.org/drawingml/2006/main">
             <a:pPr algn="l">
+              <a:buNone/>
               <a:defRPr sz="1350" b="1">
                 <a:solidFill>
                   <a:srgbClr val="101828"/>
@@ -21104,6 +21468,7 @@
           </a:p>
           <a:p xmlns:a="http://schemas.openxmlformats.org/drawingml/2006/main">
             <a:pPr algn="l">
+              <a:buNone/>
               <a:defRPr sz="1350" b="1">
                 <a:solidFill>
                   <a:srgbClr val="101828"/>
@@ -21162,6 +21527,7 @@
           <a:lstStyle xmlns:a="http://schemas.openxmlformats.org/drawingml/2006/main"/>
           <a:p xmlns:a="http://schemas.openxmlformats.org/drawingml/2006/main">
             <a:pPr algn="ctr">
+              <a:buNone/>
               <a:defRPr sz="1875" b="1">
                 <a:solidFill>
                   <a:srgbClr val="98A2B3"/>
@@ -21255,6 +21621,7 @@
           <a:lstStyle xmlns:a="http://schemas.openxmlformats.org/drawingml/2006/main"/>
           <a:p xmlns:a="http://schemas.openxmlformats.org/drawingml/2006/main">
             <a:pPr algn="l">
+              <a:buNone/>
               <a:defRPr sz="1575" b="1">
                 <a:solidFill>
                   <a:srgbClr val="1666D3"/>
@@ -21313,6 +21680,7 @@
           <a:lstStyle xmlns:a="http://schemas.openxmlformats.org/drawingml/2006/main"/>
           <a:p xmlns:a="http://schemas.openxmlformats.org/drawingml/2006/main">
             <a:pPr algn="l">
+              <a:buNone/>
               <a:defRPr sz="1350" b="1">
                 <a:solidFill>
                   <a:srgbClr val="101828"/>
@@ -21336,6 +21704,7 @@
           </a:p>
           <a:p xmlns:a="http://schemas.openxmlformats.org/drawingml/2006/main">
             <a:pPr algn="l">
+              <a:buNone/>
               <a:defRPr sz="1350" b="1">
                 <a:solidFill>
                   <a:srgbClr val="101828"/>
@@ -21359,6 +21728,7 @@
           </a:p>
           <a:p xmlns:a="http://schemas.openxmlformats.org/drawingml/2006/main">
             <a:pPr algn="l">
+              <a:buNone/>
               <a:defRPr sz="1350" b="1">
                 <a:solidFill>
                   <a:srgbClr val="101828"/>
@@ -21417,6 +21787,7 @@
           <a:lstStyle xmlns:a="http://schemas.openxmlformats.org/drawingml/2006/main"/>
           <a:p xmlns:a="http://schemas.openxmlformats.org/drawingml/2006/main">
             <a:pPr algn="ctr">
+              <a:buNone/>
               <a:defRPr sz="1875" b="1">
                 <a:solidFill>
                   <a:srgbClr val="98A2B3"/>
@@ -21510,6 +21881,7 @@
           <a:lstStyle xmlns:a="http://schemas.openxmlformats.org/drawingml/2006/main"/>
           <a:p xmlns:a="http://schemas.openxmlformats.org/drawingml/2006/main">
             <a:pPr algn="l">
+              <a:buNone/>
               <a:defRPr sz="1575" b="1">
                 <a:solidFill>
                   <a:srgbClr val="7047B8"/>
@@ -21568,6 +21940,7 @@
           <a:lstStyle xmlns:a="http://schemas.openxmlformats.org/drawingml/2006/main"/>
           <a:p xmlns:a="http://schemas.openxmlformats.org/drawingml/2006/main">
             <a:pPr algn="l">
+              <a:buNone/>
               <a:defRPr sz="1350" b="1">
                 <a:solidFill>
                   <a:srgbClr val="101828"/>
@@ -21591,6 +21964,7 @@
           </a:p>
           <a:p xmlns:a="http://schemas.openxmlformats.org/drawingml/2006/main">
             <a:pPr algn="l">
+              <a:buNone/>
               <a:defRPr sz="1350" b="1">
                 <a:solidFill>
                   <a:srgbClr val="101828"/>
@@ -21614,6 +21988,7 @@
           </a:p>
           <a:p xmlns:a="http://schemas.openxmlformats.org/drawingml/2006/main">
             <a:pPr algn="l">
+              <a:buNone/>
               <a:defRPr sz="1350" b="1">
                 <a:solidFill>
                   <a:srgbClr val="101828"/>
@@ -21632,7 +22007,7 @@
                 <a:ea typeface="Microsoft YaHei"/>
                 <a:cs typeface="Microsoft YaHei"/>
               </a:rPr>
-              <a:t>confidence + confirmed</a:t>
+              <a:t>strength + confirmed</a:t>
             </a:r>
           </a:p>
         </p:txBody>
@@ -21672,6 +22047,7 @@
           <a:lstStyle xmlns:a="http://schemas.openxmlformats.org/drawingml/2006/main"/>
           <a:p xmlns:a="http://schemas.openxmlformats.org/drawingml/2006/main">
             <a:pPr algn="l">
+              <a:buNone/>
               <a:defRPr sz="1050" b="1">
                 <a:solidFill>
                   <a:srgbClr val="98A2B3"/>
@@ -21736,6 +22112,7 @@
           <a:lstStyle xmlns:a="http://schemas.openxmlformats.org/drawingml/2006/main"/>
           <a:p xmlns:a="http://schemas.openxmlformats.org/drawingml/2006/main">
             <a:pPr algn="l">
+              <a:buNone/>
               <a:defRPr sz="1350" b="0">
                 <a:solidFill>
                   <a:srgbClr val="E8EEF6"/>
@@ -21754,43 +22131,43 @@
                 <a:ea typeface="Consolas"/>
                 <a:cs typeface="Consolas"/>
               </a:rPr>
-              <a:t>claim: 具备 Python 项目经验</a:t>
-            </a:r>
-          </a:p>
-          <a:p xmlns:a="http://schemas.openxmlformats.org/drawingml/2006/main">
-            <a:pPr algn="l">
-              <a:defRPr sz="1350" b="0">
+              <a:t>claim: </a:t>
+            </a:r>
+            <a:r>
+              <a:rPr sz="1350" b="0">
                 <a:solidFill>
                   <a:srgbClr val="E8EEF6"/>
                 </a:solidFill>
                 <a:latin typeface="Consolas"/>
                 <a:ea typeface="Consolas"/>
                 <a:cs typeface="Consolas"/>
-              </a:defRPr>
-            </a:pPr>
-            <a:r>
-              <a:rPr sz="1350" b="0">
+              </a:rPr>
+              <a:t>具备办公与信息处理经验</a:t>
+            </a:r>
+          </a:p>
+          <a:p xmlns:a="http://schemas.openxmlformats.org/drawingml/2006/main">
+            <a:pPr algn="l">
+              <a:buNone/>
+              <a:defRPr sz="1350" b="0">
                 <a:solidFill>
                   <a:srgbClr val="E8EEF6"/>
                 </a:solidFill>
                 <a:latin typeface="Consolas"/>
                 <a:ea typeface="Consolas"/>
                 <a:cs typeface="Consolas"/>
-              </a:rPr>
-              <a:t>evidence: resume:block-12</a:t>
-            </a:r>
-          </a:p>
-          <a:p xmlns:a="http://schemas.openxmlformats.org/drawingml/2006/main">
-            <a:pPr algn="l">
-              <a:defRPr sz="1350" b="0">
+              </a:defRPr>
+            </a:pPr>
+            <a:r>
+              <a:rPr sz="1350" b="0">
                 <a:solidFill>
                   <a:srgbClr val="E8EEF6"/>
                 </a:solidFill>
                 <a:latin typeface="Consolas"/>
                 <a:ea typeface="Consolas"/>
                 <a:cs typeface="Consolas"/>
-              </a:defRPr>
-            </a:pPr>
+              </a:rPr>
+              <a:t>evidence: </a:t>
+            </a:r>
             <a:r>
               <a:rPr sz="1350" b="0">
                 <a:solidFill>
@@ -21800,11 +22177,12 @@
                 <a:ea typeface="Consolas"/>
                 <a:cs typeface="Consolas"/>
               </a:rPr>
-              <a:t>source: “使用 Python 完成校园数据分析项目”</a:t>
+              <a:t>E-S001-003</a:t>
             </a:r>
           </a:p>
           <a:p xmlns:a="http://schemas.openxmlformats.org/drawingml/2006/main">
             <a:pPr algn="l">
+              <a:buNone/>
               <a:defRPr sz="1350" b="0">
                 <a:solidFill>
                   <a:srgbClr val="E8EEF6"/>
@@ -21823,7 +22201,64 @@
                 <a:ea typeface="Consolas"/>
                 <a:cs typeface="Consolas"/>
               </a:rPr>
-              <a:t>confidence: 0.91    confirmed: true</a:t>
+              <a:t>source: “</a:t>
+            </a:r>
+            <a:r>
+              <a:rPr sz="1350" b="0">
+                <a:solidFill>
+                  <a:srgbClr val="E8EEF6"/>
+                </a:solidFill>
+                <a:latin typeface="Consolas"/>
+                <a:ea typeface="Consolas"/>
+                <a:cs typeface="Consolas"/>
+              </a:rPr>
+              <a:t>我使用 Excel 维护活动报名名单，核对参与者信息。</a:t>
+            </a:r>
+            <a:r>
+              <a:rPr sz="1350" b="0">
+                <a:solidFill>
+                  <a:srgbClr val="E8EEF6"/>
+                </a:solidFill>
+                <a:latin typeface="Consolas"/>
+                <a:ea typeface="Consolas"/>
+                <a:cs typeface="Consolas"/>
+              </a:rPr>
+              <a:t>”</a:t>
+            </a:r>
+          </a:p>
+          <a:p xmlns:a="http://schemas.openxmlformats.org/drawingml/2006/main">
+            <a:pPr algn="l">
+              <a:buNone/>
+              <a:defRPr sz="1350" b="0">
+                <a:solidFill>
+                  <a:srgbClr val="E8EEF6"/>
+                </a:solidFill>
+                <a:latin typeface="Consolas"/>
+                <a:ea typeface="Consolas"/>
+                <a:cs typeface="Consolas"/>
+              </a:defRPr>
+            </a:pPr>
+            <a:r>
+              <a:rPr sz="1350" b="0">
+                <a:solidFill>
+                  <a:srgbClr val="E8EEF6"/>
+                </a:solidFill>
+                <a:latin typeface="Consolas"/>
+                <a:ea typeface="Consolas"/>
+                <a:cs typeface="Consolas"/>
+              </a:rPr>
+              <a:t>strength: direct</a:t>
+            </a:r>
+            <a:r>
+              <a:rPr sz="1350" b="0">
+                <a:solidFill>
+                  <a:srgbClr val="E8EEF6"/>
+                </a:solidFill>
+                <a:latin typeface="Consolas"/>
+                <a:ea typeface="Consolas"/>
+                <a:cs typeface="Consolas"/>
+              </a:rPr>
+              <a:t>    confirmed: true</a:t>
             </a:r>
           </a:p>
         </p:txBody>
@@ -21898,6 +22333,7 @@
           <a:lstStyle xmlns:a="http://schemas.openxmlformats.org/drawingml/2006/main"/>
           <a:p xmlns:a="http://schemas.openxmlformats.org/drawingml/2006/main">
             <a:pPr algn="ctr">
+              <a:buNone/>
               <a:defRPr sz="1500" b="1">
                 <a:solidFill>
                   <a:srgbClr val="16865B"/>
@@ -21956,6 +22392,7 @@
           <a:lstStyle xmlns:a="http://schemas.openxmlformats.org/drawingml/2006/main"/>
           <a:p xmlns:a="http://schemas.openxmlformats.org/drawingml/2006/main">
             <a:pPr algn="ctr">
+              <a:buNone/>
               <a:defRPr sz="1275" b="1">
                 <a:solidFill>
                   <a:srgbClr val="101828"/>
@@ -21979,6 +22416,7 @@
           </a:p>
           <a:p xmlns:a="http://schemas.openxmlformats.org/drawingml/2006/main">
             <a:pPr algn="ctr">
+              <a:buNone/>
               <a:defRPr sz="1275" b="1">
                 <a:solidFill>
                   <a:srgbClr val="101828"/>
@@ -22002,6 +22440,7 @@
           </a:p>
           <a:p xmlns:a="http://schemas.openxmlformats.org/drawingml/2006/main">
             <a:pPr algn="ctr">
+              <a:buNone/>
               <a:defRPr sz="1275" b="1">
                 <a:solidFill>
                   <a:srgbClr val="101828"/>
@@ -22025,6 +22464,7 @@
           </a:p>
           <a:p xmlns:a="http://schemas.openxmlformats.org/drawingml/2006/main">
             <a:pPr algn="ctr">
+              <a:buNone/>
               <a:defRPr sz="1275" b="1">
                 <a:solidFill>
                   <a:srgbClr val="101828"/>
@@ -22116,6 +22556,7 @@
           <a:lstStyle xmlns:a="http://schemas.openxmlformats.org/drawingml/2006/main"/>
           <a:p xmlns:a="http://schemas.openxmlformats.org/drawingml/2006/main">
             <a:pPr algn="l">
+              <a:buNone/>
               <a:defRPr sz="900" b="1">
                 <a:solidFill>
                   <a:srgbClr val="1666D3"/>
@@ -22174,6 +22615,7 @@
           <a:lstStyle xmlns:a="http://schemas.openxmlformats.org/drawingml/2006/main"/>
           <a:p xmlns:a="http://schemas.openxmlformats.org/drawingml/2006/main">
             <a:pPr algn="l">
+              <a:buNone/>
               <a:defRPr sz="2400" b="1">
                 <a:solidFill>
                   <a:srgbClr val="101828"/>
@@ -22199,7 +22641,7 @@
       </p:sp>
       <p:cxnSp>
         <p:nvCxnSpPr>
-          <p:cNvPr id="42" name="header-line-8"/>
+          <p:cNvPr id="82" name="header-line-8"/>
           <p:cNvCxnSpPr/>
           <p:nvPr/>
         </p:nvCxnSpPr>
@@ -22254,6 +22696,7 @@
           <a:lstStyle xmlns:a="http://schemas.openxmlformats.org/drawingml/2006/main"/>
           <a:p xmlns:a="http://schemas.openxmlformats.org/drawingml/2006/main">
             <a:pPr algn="l">
+              <a:buNone/>
               <a:defRPr sz="750" b="0">
                 <a:solidFill>
                   <a:srgbClr val="98A2B3"/>
@@ -22312,6 +22755,7 @@
           <a:lstStyle xmlns:a="http://schemas.openxmlformats.org/drawingml/2006/main"/>
           <a:p xmlns:a="http://schemas.openxmlformats.org/drawingml/2006/main">
             <a:pPr algn="r">
+              <a:buNone/>
               <a:defRPr sz="825" b="1">
                 <a:solidFill>
                   <a:srgbClr val="98A2B3"/>
@@ -22399,6 +22843,7 @@
           <a:lstStyle xmlns:a="http://schemas.openxmlformats.org/drawingml/2006/main"/>
           <a:p xmlns:a="http://schemas.openxmlformats.org/drawingml/2006/main">
             <a:pPr algn="l">
+              <a:buNone/>
               <a:defRPr sz="900" b="1">
                 <a:solidFill>
                   <a:srgbClr val="1666D3"/>
@@ -22457,6 +22902,7 @@
           <a:lstStyle xmlns:a="http://schemas.openxmlformats.org/drawingml/2006/main"/>
           <a:p xmlns:a="http://schemas.openxmlformats.org/drawingml/2006/main">
             <a:pPr algn="l">
+              <a:buNone/>
               <a:defRPr sz="2550" b="1">
                 <a:solidFill>
                   <a:srgbClr val="101828"/>
@@ -22475,14 +22921,14 @@
                 <a:ea typeface="Microsoft YaHei"/>
                 <a:cs typeface="Microsoft YaHei"/>
               </a:rPr>
-              <a:t>匹配度与证据置信度分开展示</a:t>
+              <a:t>匹配度与证据覆盖度分开展示</a:t>
             </a:r>
           </a:p>
         </p:txBody>
       </p:sp>
       <p:cxnSp>
         <p:nvCxnSpPr>
-          <p:cNvPr id="37" name="header-line-9"/>
+          <p:cNvPr id="95" name="header-line-9"/>
           <p:cNvCxnSpPr/>
           <p:nvPr/>
         </p:nvCxnSpPr>
@@ -22572,6 +23018,7 @@
           <a:lstStyle xmlns:a="http://schemas.openxmlformats.org/drawingml/2006/main"/>
           <a:p xmlns:a="http://schemas.openxmlformats.org/drawingml/2006/main">
             <a:pPr algn="ctr">
+              <a:buNone/>
               <a:defRPr sz="1425" b="1">
                 <a:solidFill>
                   <a:srgbClr val="101828"/>
@@ -22696,6 +23143,7 @@
           <a:lstStyle xmlns:a="http://schemas.openxmlformats.org/drawingml/2006/main"/>
           <a:p xmlns:a="http://schemas.openxmlformats.org/drawingml/2006/main">
             <a:pPr algn="ctr">
+              <a:buNone/>
               <a:defRPr sz="3300" b="1">
                 <a:solidFill>
                   <a:srgbClr val="0B3B75"/>
@@ -22714,7 +23162,7 @@
                 <a:ea typeface="Microsoft YaHei"/>
                 <a:cs typeface="Microsoft YaHei"/>
               </a:rPr>
-              <a:t>76</a:t>
+              <a:t>77</a:t>
             </a:r>
           </a:p>
         </p:txBody>
@@ -22754,6 +23202,7 @@
           <a:lstStyle xmlns:a="http://schemas.openxmlformats.org/drawingml/2006/main"/>
           <a:p xmlns:a="http://schemas.openxmlformats.org/drawingml/2006/main">
             <a:pPr algn="ctr">
+              <a:buNone/>
               <a:defRPr sz="1050" b="1">
                 <a:solidFill>
                   <a:srgbClr val="98A2B3"/>
@@ -22812,6 +23261,7 @@
           <a:lstStyle xmlns:a="http://schemas.openxmlformats.org/drawingml/2006/main"/>
           <a:p xmlns:a="http://schemas.openxmlformats.org/drawingml/2006/main">
             <a:pPr algn="ctr">
+              <a:buNone/>
               <a:defRPr sz="1200" b="1">
                 <a:solidFill>
                   <a:srgbClr val="101828"/>
@@ -22830,7 +23280,7 @@
                 <a:ea typeface="Microsoft YaHei"/>
                 <a:cs typeface="Microsoft YaHei"/>
               </a:rPr>
-              <a:t>证据置信度 82%</a:t>
+              <a:t>证据覆盖度 85%</a:t>
             </a:r>
           </a:p>
         </p:txBody>
@@ -22887,7 +23337,7 @@
         <p:spPr>
           <a:xfrm xmlns:a="http://schemas.openxmlformats.org/drawingml/2006/main">
             <a:off x="819150" y="4886325"/>
-            <a:ext cx="1695450" cy="123825"/>
+            <a:ext cx="1752600" cy="123825"/>
           </a:xfrm>
           <a:prstGeom xmlns:a="http://schemas.openxmlformats.org/drawingml/2006/main" prst="roundRect">
             <a:avLst>
@@ -22940,6 +23390,7 @@
           <a:lstStyle xmlns:a="http://schemas.openxmlformats.org/drawingml/2006/main"/>
           <a:p xmlns:a="http://schemas.openxmlformats.org/drawingml/2006/main">
             <a:pPr algn="ctr">
+              <a:buNone/>
               <a:defRPr sz="1125" b="1">
                 <a:solidFill>
                   <a:srgbClr val="C83838"/>
@@ -23033,6 +23484,7 @@
           <a:lstStyle xmlns:a="http://schemas.openxmlformats.org/drawingml/2006/main"/>
           <a:p xmlns:a="http://schemas.openxmlformats.org/drawingml/2006/main">
             <a:pPr algn="ctr">
+              <a:buNone/>
               <a:defRPr sz="1425" b="1">
                 <a:solidFill>
                   <a:srgbClr val="101828"/>
@@ -23058,7 +23510,7 @@
       </p:sp>
       <p:graphicFrame>
         <p:nvGraphicFramePr>
-          <p:cNvPr id="50" name="Chart"/>
+          <p:cNvPr id="108" name="Chart"/>
           <p:cNvGraphicFramePr/>
           <p:nvPr/>
         </p:nvGraphicFramePr>
@@ -23068,7 +23520,7 @@
         </p:xfrm>
         <a:graphic xmlns:a="http://schemas.openxmlformats.org/drawingml/2006/main">
           <a:graphicData uri="http://schemas.openxmlformats.org/drawingml/2006/chart">
-            <c:chart xmlns:r="http://schemas.openxmlformats.org/officeDocument/2006/relationships" xmlns:c="http://schemas.openxmlformats.org/drawingml/2006/chart" r:id="Rb9be4e47758d4b7a"/>
+            <c:chart xmlns:r="http://schemas.openxmlformats.org/officeDocument/2006/relationships" xmlns:c="http://schemas.openxmlformats.org/drawingml/2006/chart" r:id="R8c692493759c4b0f"/>
           </a:graphicData>
         </a:graphic>
       </p:graphicFrame>
@@ -23107,6 +23559,7 @@
           <a:lstStyle xmlns:a="http://schemas.openxmlformats.org/drawingml/2006/main"/>
           <a:p xmlns:a="http://schemas.openxmlformats.org/drawingml/2006/main">
             <a:pPr algn="ctr">
+              <a:buNone/>
               <a:defRPr sz="1050" b="0">
                 <a:solidFill>
                   <a:srgbClr val="667085"/>
@@ -23200,6 +23653,7 @@
           <a:lstStyle xmlns:a="http://schemas.openxmlformats.org/drawingml/2006/main"/>
           <a:p xmlns:a="http://schemas.openxmlformats.org/drawingml/2006/main">
             <a:pPr algn="ctr">
+              <a:buNone/>
               <a:defRPr sz="1425" b="1">
                 <a:solidFill>
                   <a:srgbClr val="101828"/>
@@ -23258,6 +23712,7 @@
           <a:lstStyle xmlns:a="http://schemas.openxmlformats.org/drawingml/2006/main"/>
           <a:p xmlns:a="http://schemas.openxmlformats.org/drawingml/2006/main">
             <a:pPr algn="l">
+              <a:buNone/>
               <a:defRPr sz="1275" b="1">
                 <a:solidFill>
                   <a:srgbClr val="101828"/>
@@ -23276,7 +23731,7 @@
                 <a:ea typeface="Microsoft YaHei"/>
                 <a:cs typeface="Microsoft YaHei"/>
               </a:rPr>
-              <a:t>Python 项目</a:t>
+              <a:t>Excel 信息整理</a:t>
             </a:r>
           </a:p>
         </p:txBody>
@@ -23322,6 +23777,7 @@
           <a:lstStyle xmlns:a="http://schemas.openxmlformats.org/drawingml/2006/main"/>
           <a:p xmlns:a="http://schemas.openxmlformats.org/drawingml/2006/main">
             <a:pPr algn="ctr">
+              <a:buNone/>
               <a:defRPr sz="1050" b="1">
                 <a:solidFill>
                   <a:srgbClr val="16865B"/>
@@ -23347,7 +23803,7 @@
       </p:sp>
       <p:cxnSp>
         <p:nvCxnSpPr>
-          <p:cNvPr id="56" name="req-line-0"/>
+          <p:cNvPr id="114" name="req-line-0"/>
           <p:cNvCxnSpPr/>
           <p:nvPr/>
         </p:nvCxnSpPr>
@@ -23402,6 +23858,7 @@
           <a:lstStyle xmlns:a="http://schemas.openxmlformats.org/drawingml/2006/main"/>
           <a:p xmlns:a="http://schemas.openxmlformats.org/drawingml/2006/main">
             <a:pPr algn="l">
+              <a:buNone/>
               <a:defRPr sz="1275" b="1">
                 <a:solidFill>
                   <a:srgbClr val="101828"/>
@@ -23420,7 +23877,7 @@
                 <a:ea typeface="Microsoft YaHei"/>
                 <a:cs typeface="Microsoft YaHei"/>
               </a:rPr>
-              <a:t>SQL 实践</a:t>
+              <a:t>基础文档写作</a:t>
             </a:r>
           </a:p>
         </p:txBody>
@@ -23466,6 +23923,7 @@
           <a:lstStyle xmlns:a="http://schemas.openxmlformats.org/drawingml/2006/main"/>
           <a:p xmlns:a="http://schemas.openxmlformats.org/drawingml/2006/main">
             <a:pPr algn="ctr">
+              <a:buNone/>
               <a:defRPr sz="1050" b="1">
                 <a:solidFill>
                   <a:srgbClr val="C77800"/>
@@ -23491,7 +23949,7 @@
       </p:sp>
       <p:cxnSp>
         <p:nvCxnSpPr>
-          <p:cNvPr id="59" name="req-line-1"/>
+          <p:cNvPr id="117" name="req-line-1"/>
           <p:cNvCxnSpPr/>
           <p:nvPr/>
         </p:nvCxnSpPr>
@@ -23546,6 +24004,7 @@
           <a:lstStyle xmlns:a="http://schemas.openxmlformats.org/drawingml/2006/main"/>
           <a:p xmlns:a="http://schemas.openxmlformats.org/drawingml/2006/main">
             <a:pPr algn="l">
+              <a:buNone/>
               <a:defRPr sz="1275" b="1">
                 <a:solidFill>
                   <a:srgbClr val="101828"/>
@@ -23564,7 +24023,7 @@
                 <a:ea typeface="Microsoft YaHei"/>
                 <a:cs typeface="Microsoft YaHei"/>
               </a:rPr>
-              <a:t>云部署</a:t>
+              <a:t>内容发布经验</a:t>
             </a:r>
           </a:p>
         </p:txBody>
@@ -23610,6 +24069,7 @@
           <a:lstStyle xmlns:a="http://schemas.openxmlformats.org/drawingml/2006/main"/>
           <a:p xmlns:a="http://schemas.openxmlformats.org/drawingml/2006/main">
             <a:pPr algn="ctr">
+              <a:buNone/>
               <a:defRPr sz="1050" b="1">
                 <a:solidFill>
                   <a:srgbClr val="667085"/>
@@ -23635,7 +24095,7 @@
       </p:sp>
       <p:cxnSp>
         <p:nvCxnSpPr>
-          <p:cNvPr id="62" name="req-line-2"/>
+          <p:cNvPr id="120" name="req-line-2"/>
           <p:cNvCxnSpPr/>
           <p:nvPr/>
         </p:nvCxnSpPr>
@@ -23690,6 +24150,7 @@
           <a:lstStyle xmlns:a="http://schemas.openxmlformats.org/drawingml/2006/main"/>
           <a:p xmlns:a="http://schemas.openxmlformats.org/drawingml/2006/main">
             <a:pPr algn="l">
+              <a:buNone/>
               <a:defRPr sz="1275" b="1">
                 <a:solidFill>
                   <a:srgbClr val="101828"/>
@@ -23708,7 +24169,7 @@
                 <a:ea typeface="Microsoft YaHei"/>
                 <a:cs typeface="Microsoft YaHei"/>
               </a:rPr>
-              <a:t>限男性</a:t>
+              <a:t>女性优先</a:t>
             </a:r>
           </a:p>
         </p:txBody>
@@ -23754,6 +24215,7 @@
           <a:lstStyle xmlns:a="http://schemas.openxmlformats.org/drawingml/2006/main"/>
           <a:p xmlns:a="http://schemas.openxmlformats.org/drawingml/2006/main">
             <a:pPr algn="ctr">
+              <a:buNone/>
               <a:defRPr sz="1050" b="1">
                 <a:solidFill>
                   <a:srgbClr val="C83838"/>
@@ -23812,6 +24274,7 @@
           <a:lstStyle xmlns:a="http://schemas.openxmlformats.org/drawingml/2006/main"/>
           <a:p xmlns:a="http://schemas.openxmlformats.org/drawingml/2006/main">
             <a:pPr algn="ctr">
+              <a:buNone/>
               <a:defRPr sz="975" b="0">
                 <a:solidFill>
                   <a:srgbClr val="667085"/>
@@ -23870,6 +24333,7 @@
           <a:lstStyle xmlns:a="http://schemas.openxmlformats.org/drawingml/2006/main"/>
           <a:p xmlns:a="http://schemas.openxmlformats.org/drawingml/2006/main">
             <a:pPr algn="ctr">
+              <a:buNone/>
               <a:defRPr sz="975" b="1">
                 <a:solidFill>
                   <a:srgbClr val="C83838"/>
@@ -23928,6 +24392,7 @@
           <a:lstStyle xmlns:a="http://schemas.openxmlformats.org/drawingml/2006/main"/>
           <a:p xmlns:a="http://schemas.openxmlformats.org/drawingml/2006/main">
             <a:pPr algn="l">
+              <a:buNone/>
               <a:defRPr sz="750" b="0">
                 <a:solidFill>
                   <a:srgbClr val="98A2B3"/>
@@ -23986,6 +24451,7 @@
           <a:lstStyle xmlns:a="http://schemas.openxmlformats.org/drawingml/2006/main"/>
           <a:p xmlns:a="http://schemas.openxmlformats.org/drawingml/2006/main">
             <a:pPr algn="r">
+              <a:buNone/>
               <a:defRPr sz="825" b="1">
                 <a:solidFill>
                   <a:srgbClr val="98A2B3"/>

</xml_diff>